<commit_message>
Replace Charlson `score` with `ecog_score` in adjuster set
Every adjuster set in sherley_carbo.qmd now uses `ecog_score` (ECOG
performance status, remapped 0–5) in place of `score` (Charlson
comorbidity index): .adj_set, csh_model, the 8 plot_subhr_* /
plot_cox_* / adj_cif / adj_death_curve helpers. The diagnostic
event-count caption and descriptive paragraph reflect the new variable
name. All 11 docx tables and 54 pptx slides still generate; zero
Lapack errors; 4 fallback placeholders remain (rare grade-3 outcomes
unchanged).

Co-Authored-By: Claude Opus 4.7 (1M context) <noreply@anthropic.com>
</commit_message>
<xml_diff>
--- a/docs/plots/carbo/jx_carbo_adjcif_aki2.pptx
+++ b/docs/plots/carbo/jx_carbo_adjcif_aki2.pptx
@@ -2271,21 +2271,21 @@
           </p:nvSpPr>
           <p:spPr>
             <a:xfrm>
-              <a:off x="972874" y="5181818"/>
-              <a:ext cx="7644336" cy="0"/>
+              <a:off x="1035053" y="5179811"/>
+              <a:ext cx="7582157" cy="0"/>
             </a:xfrm>
             <a:custGeom>
               <a:avLst/>
               <a:pathLst>
-                <a:path w="7644336" h="0">
+                <a:path w="7582157" h="0">
                   <a:moveTo>
                     <a:pt x="0" y="0"/>
                   </a:moveTo>
                   <a:lnTo>
-                    <a:pt x="7644336" y="0"/>
-                  </a:lnTo>
-                  <a:lnTo>
-                    <a:pt x="7644336" y="0"/>
+                    <a:pt x="7582157" y="0"/>
+                  </a:lnTo>
+                  <a:lnTo>
+                    <a:pt x="7582157" y="0"/>
                   </a:lnTo>
                 </a:path>
               </a:pathLst>
@@ -2314,21 +2314,21 @@
           </p:nvSpPr>
           <p:spPr>
             <a:xfrm>
-              <a:off x="972874" y="4384610"/>
-              <a:ext cx="7644336" cy="0"/>
+              <a:off x="1035053" y="4378590"/>
+              <a:ext cx="7582157" cy="0"/>
             </a:xfrm>
             <a:custGeom>
               <a:avLst/>
               <a:pathLst>
-                <a:path w="7644336" h="0">
+                <a:path w="7582157" h="0">
                   <a:moveTo>
                     <a:pt x="0" y="0"/>
                   </a:moveTo>
                   <a:lnTo>
-                    <a:pt x="7644336" y="0"/>
-                  </a:lnTo>
-                  <a:lnTo>
-                    <a:pt x="7644336" y="0"/>
+                    <a:pt x="7582157" y="0"/>
+                  </a:lnTo>
+                  <a:lnTo>
+                    <a:pt x="7582157" y="0"/>
                   </a:lnTo>
                 </a:path>
               </a:pathLst>
@@ -2357,21 +2357,21 @@
           </p:nvSpPr>
           <p:spPr>
             <a:xfrm>
-              <a:off x="972874" y="3587402"/>
-              <a:ext cx="7644336" cy="0"/>
+              <a:off x="1035053" y="3577369"/>
+              <a:ext cx="7582157" cy="0"/>
             </a:xfrm>
             <a:custGeom>
               <a:avLst/>
               <a:pathLst>
-                <a:path w="7644336" h="0">
+                <a:path w="7582157" h="0">
                   <a:moveTo>
                     <a:pt x="0" y="0"/>
                   </a:moveTo>
                   <a:lnTo>
-                    <a:pt x="7644336" y="0"/>
-                  </a:lnTo>
-                  <a:lnTo>
-                    <a:pt x="7644336" y="0"/>
+                    <a:pt x="7582157" y="0"/>
+                  </a:lnTo>
+                  <a:lnTo>
+                    <a:pt x="7582157" y="0"/>
                   </a:lnTo>
                 </a:path>
               </a:pathLst>
@@ -2400,21 +2400,21 @@
           </p:nvSpPr>
           <p:spPr>
             <a:xfrm>
-              <a:off x="972874" y="2790194"/>
-              <a:ext cx="7644336" cy="0"/>
+              <a:off x="1035053" y="2776148"/>
+              <a:ext cx="7582157" cy="0"/>
             </a:xfrm>
             <a:custGeom>
               <a:avLst/>
               <a:pathLst>
-                <a:path w="7644336" h="0">
+                <a:path w="7582157" h="0">
                   <a:moveTo>
                     <a:pt x="0" y="0"/>
                   </a:moveTo>
                   <a:lnTo>
-                    <a:pt x="7644336" y="0"/>
-                  </a:lnTo>
-                  <a:lnTo>
-                    <a:pt x="7644336" y="0"/>
+                    <a:pt x="7582157" y="0"/>
+                  </a:lnTo>
+                  <a:lnTo>
+                    <a:pt x="7582157" y="0"/>
                   </a:lnTo>
                 </a:path>
               </a:pathLst>
@@ -2443,7 +2443,7 @@
           </p:nvSpPr>
           <p:spPr>
             <a:xfrm>
-              <a:off x="1591099" y="2583293"/>
+              <a:off x="1648250" y="2583293"/>
               <a:ext cx="0" cy="3139848"/>
             </a:xfrm>
             <a:custGeom>
@@ -2486,7 +2486,7 @@
           </p:nvSpPr>
           <p:spPr>
             <a:xfrm>
-              <a:off x="3396138" y="2583293"/>
+              <a:off x="3438606" y="2583293"/>
               <a:ext cx="0" cy="3139848"/>
             </a:xfrm>
             <a:custGeom>
@@ -2529,7 +2529,7 @@
           </p:nvSpPr>
           <p:spPr>
             <a:xfrm>
-              <a:off x="5201176" y="2583293"/>
+              <a:off x="5228962" y="2583293"/>
               <a:ext cx="0" cy="3139848"/>
             </a:xfrm>
             <a:custGeom>
@@ -2572,7 +2572,7 @@
           </p:nvSpPr>
           <p:spPr>
             <a:xfrm>
-              <a:off x="7006214" y="2583293"/>
+              <a:off x="7019318" y="2583293"/>
               <a:ext cx="0" cy="3139848"/>
             </a:xfrm>
             <a:custGeom>
@@ -2615,21 +2615,21 @@
           </p:nvSpPr>
           <p:spPr>
             <a:xfrm>
-              <a:off x="972874" y="5580422"/>
-              <a:ext cx="7644336" cy="0"/>
+              <a:off x="1035053" y="5580422"/>
+              <a:ext cx="7582157" cy="0"/>
             </a:xfrm>
             <a:custGeom>
               <a:avLst/>
               <a:pathLst>
-                <a:path w="7644336" h="0">
+                <a:path w="7582157" h="0">
                   <a:moveTo>
                     <a:pt x="0" y="0"/>
                   </a:moveTo>
                   <a:lnTo>
-                    <a:pt x="7644336" y="0"/>
-                  </a:lnTo>
-                  <a:lnTo>
-                    <a:pt x="7644336" y="0"/>
+                    <a:pt x="7582157" y="0"/>
+                  </a:lnTo>
+                  <a:lnTo>
+                    <a:pt x="7582157" y="0"/>
                   </a:lnTo>
                 </a:path>
               </a:pathLst>
@@ -2658,21 +2658,21 @@
           </p:nvSpPr>
           <p:spPr>
             <a:xfrm>
-              <a:off x="972874" y="4783214"/>
-              <a:ext cx="7644336" cy="0"/>
+              <a:off x="1035053" y="4779201"/>
+              <a:ext cx="7582157" cy="0"/>
             </a:xfrm>
             <a:custGeom>
               <a:avLst/>
               <a:pathLst>
-                <a:path w="7644336" h="0">
+                <a:path w="7582157" h="0">
                   <a:moveTo>
                     <a:pt x="0" y="0"/>
                   </a:moveTo>
                   <a:lnTo>
-                    <a:pt x="7644336" y="0"/>
-                  </a:lnTo>
-                  <a:lnTo>
-                    <a:pt x="7644336" y="0"/>
+                    <a:pt x="7582157" y="0"/>
+                  </a:lnTo>
+                  <a:lnTo>
+                    <a:pt x="7582157" y="0"/>
                   </a:lnTo>
                 </a:path>
               </a:pathLst>
@@ -2701,21 +2701,21 @@
           </p:nvSpPr>
           <p:spPr>
             <a:xfrm>
-              <a:off x="972874" y="3986006"/>
-              <a:ext cx="7644336" cy="0"/>
+              <a:off x="1035053" y="3977980"/>
+              <a:ext cx="7582157" cy="0"/>
             </a:xfrm>
             <a:custGeom>
               <a:avLst/>
               <a:pathLst>
-                <a:path w="7644336" h="0">
+                <a:path w="7582157" h="0">
                   <a:moveTo>
                     <a:pt x="0" y="0"/>
                   </a:moveTo>
                   <a:lnTo>
-                    <a:pt x="7644336" y="0"/>
-                  </a:lnTo>
-                  <a:lnTo>
-                    <a:pt x="7644336" y="0"/>
+                    <a:pt x="7582157" y="0"/>
+                  </a:lnTo>
+                  <a:lnTo>
+                    <a:pt x="7582157" y="0"/>
                   </a:lnTo>
                 </a:path>
               </a:pathLst>
@@ -2744,21 +2744,21 @@
           </p:nvSpPr>
           <p:spPr>
             <a:xfrm>
-              <a:off x="972874" y="3188798"/>
-              <a:ext cx="7644336" cy="0"/>
+              <a:off x="1035053" y="3176759"/>
+              <a:ext cx="7582157" cy="0"/>
             </a:xfrm>
             <a:custGeom>
               <a:avLst/>
               <a:pathLst>
-                <a:path w="7644336" h="0">
+                <a:path w="7582157" h="0">
                   <a:moveTo>
                     <a:pt x="0" y="0"/>
                   </a:moveTo>
                   <a:lnTo>
-                    <a:pt x="7644336" y="0"/>
-                  </a:lnTo>
-                  <a:lnTo>
-                    <a:pt x="7644336" y="0"/>
+                    <a:pt x="7582157" y="0"/>
+                  </a:lnTo>
+                  <a:lnTo>
+                    <a:pt x="7582157" y="0"/>
                   </a:lnTo>
                 </a:path>
               </a:pathLst>
@@ -2787,7 +2787,7 @@
           </p:nvSpPr>
           <p:spPr>
             <a:xfrm>
-              <a:off x="2493619" y="2583293"/>
+              <a:off x="2543428" y="2583293"/>
               <a:ext cx="0" cy="3139848"/>
             </a:xfrm>
             <a:custGeom>
@@ -2830,7 +2830,7 @@
           </p:nvSpPr>
           <p:spPr>
             <a:xfrm>
-              <a:off x="4298657" y="2583293"/>
+              <a:off x="4333784" y="2583293"/>
               <a:ext cx="0" cy="3139848"/>
             </a:xfrm>
             <a:custGeom>
@@ -2873,7 +2873,7 @@
           </p:nvSpPr>
           <p:spPr>
             <a:xfrm>
-              <a:off x="6103695" y="2583293"/>
+              <a:off x="6124140" y="2583293"/>
               <a:ext cx="0" cy="3139848"/>
             </a:xfrm>
             <a:custGeom>
@@ -2916,7 +2916,7 @@
           </p:nvSpPr>
           <p:spPr>
             <a:xfrm>
-              <a:off x="7908733" y="2583293"/>
+              <a:off x="7914496" y="2583293"/>
               <a:ext cx="0" cy="3139848"/>
             </a:xfrm>
             <a:custGeom>
@@ -2959,45 +2959,45 @@
           </p:nvSpPr>
           <p:spPr>
             <a:xfrm>
-              <a:off x="1320344" y="4468382"/>
-              <a:ext cx="6949396" cy="713129"/>
+              <a:off x="1379697" y="4030394"/>
+              <a:ext cx="6892870" cy="991414"/>
             </a:xfrm>
             <a:custGeom>
               <a:avLst/>
               <a:pathLst>
-                <a:path w="6949396" h="713129">
+                <a:path w="6892870" h="991414">
                   <a:moveTo>
-                    <a:pt x="0" y="713129"/>
+                    <a:pt x="0" y="991414"/>
                   </a:moveTo>
                   <a:lnTo>
-                    <a:pt x="361007" y="713129"/>
-                  </a:lnTo>
-                  <a:lnTo>
-                    <a:pt x="361007" y="576782"/>
-                  </a:lnTo>
-                  <a:lnTo>
-                    <a:pt x="992770" y="576782"/>
-                  </a:lnTo>
-                  <a:lnTo>
-                    <a:pt x="992770" y="432305"/>
-                  </a:lnTo>
-                  <a:lnTo>
-                    <a:pt x="4963854" y="432305"/>
-                  </a:lnTo>
-                  <a:lnTo>
-                    <a:pt x="4963854" y="288375"/>
-                  </a:lnTo>
-                  <a:lnTo>
-                    <a:pt x="5956625" y="288375"/>
-                  </a:lnTo>
-                  <a:lnTo>
-                    <a:pt x="5956625" y="145165"/>
-                  </a:lnTo>
-                  <a:lnTo>
-                    <a:pt x="6949396" y="145165"/>
-                  </a:lnTo>
-                  <a:lnTo>
-                    <a:pt x="6949396" y="0"/>
+                    <a:pt x="358071" y="991414"/>
+                  </a:lnTo>
+                  <a:lnTo>
+                    <a:pt x="358071" y="803131"/>
+                  </a:lnTo>
+                  <a:lnTo>
+                    <a:pt x="984695" y="803131"/>
+                  </a:lnTo>
+                  <a:lnTo>
+                    <a:pt x="984695" y="601478"/>
+                  </a:lnTo>
+                  <a:lnTo>
+                    <a:pt x="4923478" y="601478"/>
+                  </a:lnTo>
+                  <a:lnTo>
+                    <a:pt x="4923478" y="401083"/>
+                  </a:lnTo>
+                  <a:lnTo>
+                    <a:pt x="5908174" y="401083"/>
+                  </a:lnTo>
+                  <a:lnTo>
+                    <a:pt x="5908174" y="201349"/>
+                  </a:lnTo>
+                  <a:lnTo>
+                    <a:pt x="6892870" y="201349"/>
+                  </a:lnTo>
+                  <a:lnTo>
+                    <a:pt x="6892870" y="0"/>
                   </a:lnTo>
                 </a:path>
               </a:pathLst>
@@ -3026,45 +3026,45 @@
           </p:nvSpPr>
           <p:spPr>
             <a:xfrm>
-              <a:off x="1320344" y="2861938"/>
-              <a:ext cx="6949396" cy="1714814"/>
+              <a:off x="1379697" y="2861938"/>
+              <a:ext cx="6892870" cy="1716572"/>
             </a:xfrm>
             <a:custGeom>
               <a:avLst/>
               <a:pathLst>
-                <a:path w="6949396" h="1714814">
+                <a:path w="6892870" h="1716572">
                   <a:moveTo>
-                    <a:pt x="0" y="1714814"/>
+                    <a:pt x="0" y="1716572"/>
                   </a:moveTo>
                   <a:lnTo>
-                    <a:pt x="361007" y="1714814"/>
-                  </a:lnTo>
-                  <a:lnTo>
-                    <a:pt x="361007" y="1379212"/>
-                  </a:lnTo>
-                  <a:lnTo>
-                    <a:pt x="992770" y="1379212"/>
-                  </a:lnTo>
-                  <a:lnTo>
-                    <a:pt x="992770" y="1027649"/>
-                  </a:lnTo>
-                  <a:lnTo>
-                    <a:pt x="4963854" y="1027649"/>
-                  </a:lnTo>
-                  <a:lnTo>
-                    <a:pt x="4963854" y="681502"/>
-                  </a:lnTo>
-                  <a:lnTo>
-                    <a:pt x="5956625" y="681502"/>
-                  </a:lnTo>
-                  <a:lnTo>
-                    <a:pt x="5956625" y="341073"/>
-                  </a:lnTo>
-                  <a:lnTo>
-                    <a:pt x="6949396" y="341073"/>
-                  </a:lnTo>
-                  <a:lnTo>
-                    <a:pt x="6949396" y="0"/>
+                    <a:pt x="358071" y="1716572"/>
+                  </a:lnTo>
+                  <a:lnTo>
+                    <a:pt x="358071" y="1384662"/>
+                  </a:lnTo>
+                  <a:lnTo>
+                    <a:pt x="984695" y="1384662"/>
+                  </a:lnTo>
+                  <a:lnTo>
+                    <a:pt x="984695" y="1032315"/>
+                  </a:lnTo>
+                  <a:lnTo>
+                    <a:pt x="4923478" y="1032315"/>
+                  </a:lnTo>
+                  <a:lnTo>
+                    <a:pt x="4923478" y="685317"/>
+                  </a:lnTo>
+                  <a:lnTo>
+                    <a:pt x="5908174" y="685317"/>
+                  </a:lnTo>
+                  <a:lnTo>
+                    <a:pt x="5908174" y="342528"/>
+                  </a:lnTo>
+                  <a:lnTo>
+                    <a:pt x="6892870" y="342528"/>
+                  </a:lnTo>
+                  <a:lnTo>
+                    <a:pt x="6892870" y="0"/>
                   </a:lnTo>
                 </a:path>
               </a:pathLst>
@@ -3094,7 +3094,7 @@
           <p:spPr>
             <a:xfrm>
               <a:off x="692708" y="5540371"/>
-              <a:ext cx="217535" cy="80101"/>
+              <a:ext cx="279714" cy="80101"/>
             </a:xfrm>
             <a:prstGeom prst="rect">
               <a:avLst/>
@@ -3126,7 +3126,7 @@
                   <a:latin typeface="Helvetica"/>
                   <a:cs typeface="Helvetica"/>
                 </a:rPr>
-                <a:t>0.00</a:t>
+                <a:t>0.000</a:t>
               </a:r>
             </a:p>
           </p:txBody>
@@ -3139,8 +3139,8 @@
           </p:nvSpPr>
           <p:spPr>
             <a:xfrm>
-              <a:off x="692708" y="4743163"/>
-              <a:ext cx="217535" cy="80101"/>
+              <a:off x="692708" y="4739150"/>
+              <a:ext cx="279714" cy="80101"/>
             </a:xfrm>
             <a:prstGeom prst="rect">
               <a:avLst/>
@@ -3172,7 +3172,7 @@
                   <a:latin typeface="Helvetica"/>
                   <a:cs typeface="Helvetica"/>
                 </a:rPr>
-                <a:t>0.03</a:t>
+                <a:t>0.025</a:t>
               </a:r>
             </a:p>
           </p:txBody>
@@ -3185,8 +3185,8 @@
           </p:nvSpPr>
           <p:spPr>
             <a:xfrm>
-              <a:off x="692708" y="3945955"/>
-              <a:ext cx="217535" cy="80101"/>
+              <a:off x="692708" y="3937929"/>
+              <a:ext cx="279714" cy="80101"/>
             </a:xfrm>
             <a:prstGeom prst="rect">
               <a:avLst/>
@@ -3218,7 +3218,7 @@
                   <a:latin typeface="Helvetica"/>
                   <a:cs typeface="Helvetica"/>
                 </a:rPr>
-                <a:t>0.06</a:t>
+                <a:t>0.050</a:t>
               </a:r>
             </a:p>
           </p:txBody>
@@ -3231,8 +3231,8 @@
           </p:nvSpPr>
           <p:spPr>
             <a:xfrm>
-              <a:off x="692708" y="3148747"/>
-              <a:ext cx="217535" cy="80101"/>
+              <a:off x="692708" y="3136708"/>
+              <a:ext cx="279714" cy="80101"/>
             </a:xfrm>
             <a:prstGeom prst="rect">
               <a:avLst/>
@@ -3264,7 +3264,7 @@
                   <a:latin typeface="Helvetica"/>
                   <a:cs typeface="Helvetica"/>
                 </a:rPr>
-                <a:t>0.09</a:t>
+                <a:t>0.075</a:t>
               </a:r>
             </a:p>
           </p:txBody>
@@ -3277,7 +3277,7 @@
           </p:nvSpPr>
           <p:spPr>
             <a:xfrm>
-              <a:off x="2431439" y="5785772"/>
+              <a:off x="2481249" y="5785772"/>
               <a:ext cx="124358" cy="80101"/>
             </a:xfrm>
             <a:prstGeom prst="rect">
@@ -3323,7 +3323,7 @@
           </p:nvSpPr>
           <p:spPr>
             <a:xfrm>
-              <a:off x="4236477" y="5785772"/>
+              <a:off x="4271605" y="5785772"/>
               <a:ext cx="124358" cy="80101"/>
             </a:xfrm>
             <a:prstGeom prst="rect">
@@ -3369,7 +3369,7 @@
           </p:nvSpPr>
           <p:spPr>
             <a:xfrm>
-              <a:off x="6041516" y="5785772"/>
+              <a:off x="6061961" y="5785772"/>
               <a:ext cx="124358" cy="80101"/>
             </a:xfrm>
             <a:prstGeom prst="rect">
@@ -3415,7 +3415,7 @@
           </p:nvSpPr>
           <p:spPr>
             <a:xfrm>
-              <a:off x="7846554" y="5785772"/>
+              <a:off x="7852317" y="5785772"/>
               <a:ext cx="124358" cy="80101"/>
             </a:xfrm>
             <a:prstGeom prst="rect">
@@ -3461,7 +3461,7 @@
           </p:nvSpPr>
           <p:spPr>
             <a:xfrm>
-              <a:off x="4197162" y="5925448"/>
+              <a:off x="4228251" y="5925448"/>
               <a:ext cx="1195760" cy="100218"/>
             </a:xfrm>
             <a:prstGeom prst="rect">
@@ -3553,7 +3553,7 @@
           </p:nvSpPr>
           <p:spPr>
             <a:xfrm>
-              <a:off x="3578565" y="2264798"/>
+              <a:off x="3609655" y="2264798"/>
               <a:ext cx="175564" cy="0"/>
             </a:xfrm>
             <a:custGeom>
@@ -3593,7 +3593,7 @@
           </p:nvSpPr>
           <p:spPr>
             <a:xfrm>
-              <a:off x="4819138" y="2264798"/>
+              <a:off x="4850228" y="2264798"/>
               <a:ext cx="175564" cy="0"/>
             </a:xfrm>
             <a:custGeom>
@@ -3633,7 +3633,7 @@
           </p:nvSpPr>
           <p:spPr>
             <a:xfrm>
-              <a:off x="3845665" y="2224748"/>
+              <a:off x="3876754" y="2224748"/>
               <a:ext cx="881938" cy="80101"/>
             </a:xfrm>
             <a:prstGeom prst="rect">
@@ -3679,7 +3679,7 @@
           </p:nvSpPr>
           <p:spPr>
             <a:xfrm>
-              <a:off x="5086238" y="2224748"/>
+              <a:off x="5117327" y="2224748"/>
               <a:ext cx="947226" cy="80101"/>
             </a:xfrm>
             <a:prstGeom prst="rect">
@@ -3725,7 +3725,7 @@
           </p:nvSpPr>
           <p:spPr>
             <a:xfrm>
-              <a:off x="972874" y="1896563"/>
+              <a:off x="1035053" y="1896563"/>
               <a:ext cx="3984498" cy="91165"/>
             </a:xfrm>
             <a:prstGeom prst="rect">
@@ -3758,7 +3758,7 @@
                   <a:latin typeface="Helvetica"/>
                   <a:cs typeface="Helvetica"/>
                 </a:rPr>
-                <a:t>Discrep &gt;= +25 vs &lt;+25: subHR = 2.56 (95% CI 0.57-11.42), p = 0.219</a:t>
+                <a:t>Discrep &gt;= +25 vs &lt;+25: subHR = 1.82 (95% CI 0.27-12.45), p = 0.543</a:t>
               </a:r>
             </a:p>
           </p:txBody>
@@ -3771,7 +3771,7 @@
           </p:nvSpPr>
           <p:spPr>
             <a:xfrm>
-              <a:off x="972874" y="1669789"/>
+              <a:off x="1035053" y="1669789"/>
               <a:ext cx="921898" cy="120152"/>
             </a:xfrm>
             <a:prstGeom prst="rect">

</xml_diff>

<commit_message>
Switch ECOG adjuster from continuous ecog_score to binary ecog_score_cat2
Every adjuster set now uses ecog_score_cat2 (factor: "0" vs ">=1") so
the model adjusts for "any ECOG impairment" as a single dummy instead
of a 1-df linear slope across the 0–5 score. Diagnostic table caption
and descriptive text updated to match. All 11 docx tables and 54 pptx
slides still generate; 0 Lapack errors; 4 placeholder fallbacks
unchanged.

Co-Authored-By: Claude Opus 4.7 (1M context) <noreply@anthropic.com>
</commit_message>
<xml_diff>
--- a/docs/plots/carbo/jx_carbo_adjcif_aki2.pptx
+++ b/docs/plots/carbo/jx_carbo_adjcif_aki2.pptx
@@ -2271,7 +2271,7 @@
           </p:nvSpPr>
           <p:spPr>
             <a:xfrm>
-              <a:off x="1035053" y="5179811"/>
+              <a:off x="1035053" y="5210750"/>
               <a:ext cx="7582157" cy="0"/>
             </a:xfrm>
             <a:custGeom>
@@ -2314,7 +2314,7 @@
           </p:nvSpPr>
           <p:spPr>
             <a:xfrm>
-              <a:off x="1035053" y="4378590"/>
+              <a:off x="1035053" y="4471408"/>
               <a:ext cx="7582157" cy="0"/>
             </a:xfrm>
             <a:custGeom>
@@ -2357,7 +2357,7 @@
           </p:nvSpPr>
           <p:spPr>
             <a:xfrm>
-              <a:off x="1035053" y="3577369"/>
+              <a:off x="1035053" y="3732065"/>
               <a:ext cx="7582157" cy="0"/>
             </a:xfrm>
             <a:custGeom>
@@ -2400,7 +2400,7 @@
           </p:nvSpPr>
           <p:spPr>
             <a:xfrm>
-              <a:off x="1035053" y="2776148"/>
+              <a:off x="1035053" y="2992722"/>
               <a:ext cx="7582157" cy="0"/>
             </a:xfrm>
             <a:custGeom>
@@ -2658,7 +2658,7 @@
           </p:nvSpPr>
           <p:spPr>
             <a:xfrm>
-              <a:off x="1035053" y="4779201"/>
+              <a:off x="1035053" y="4841079"/>
               <a:ext cx="7582157" cy="0"/>
             </a:xfrm>
             <a:custGeom>
@@ -2701,7 +2701,7 @@
           </p:nvSpPr>
           <p:spPr>
             <a:xfrm>
-              <a:off x="1035053" y="3977980"/>
+              <a:off x="1035053" y="4101736"/>
               <a:ext cx="7582157" cy="0"/>
             </a:xfrm>
             <a:custGeom>
@@ -2744,7 +2744,7 @@
           </p:nvSpPr>
           <p:spPr>
             <a:xfrm>
-              <a:off x="1035053" y="3176759"/>
+              <a:off x="1035053" y="3362394"/>
               <a:ext cx="7582157" cy="0"/>
             </a:xfrm>
             <a:custGeom>
@@ -2787,21 +2787,21 @@
           </p:nvSpPr>
           <p:spPr>
             <a:xfrm>
-              <a:off x="2543428" y="2583293"/>
-              <a:ext cx="0" cy="3139848"/>
+              <a:off x="1035053" y="2623051"/>
+              <a:ext cx="7582157" cy="0"/>
             </a:xfrm>
             <a:custGeom>
               <a:avLst/>
               <a:pathLst>
-                <a:path w="0" h="3139848">
+                <a:path w="7582157" h="0">
                   <a:moveTo>
-                    <a:pt x="0" y="3139848"/>
+                    <a:pt x="0" y="0"/>
                   </a:moveTo>
                   <a:lnTo>
-                    <a:pt x="0" y="0"/>
-                  </a:lnTo>
-                  <a:lnTo>
-                    <a:pt x="0" y="0"/>
+                    <a:pt x="7582157" y="0"/>
+                  </a:lnTo>
+                  <a:lnTo>
+                    <a:pt x="7582157" y="0"/>
                   </a:lnTo>
                 </a:path>
               </a:pathLst>
@@ -2830,7 +2830,7 @@
           </p:nvSpPr>
           <p:spPr>
             <a:xfrm>
-              <a:off x="4333784" y="2583293"/>
+              <a:off x="2543428" y="2583293"/>
               <a:ext cx="0" cy="3139848"/>
             </a:xfrm>
             <a:custGeom>
@@ -2873,7 +2873,7 @@
           </p:nvSpPr>
           <p:spPr>
             <a:xfrm>
-              <a:off x="6124140" y="2583293"/>
+              <a:off x="4333784" y="2583293"/>
               <a:ext cx="0" cy="3139848"/>
             </a:xfrm>
             <a:custGeom>
@@ -2916,7 +2916,7 @@
           </p:nvSpPr>
           <p:spPr>
             <a:xfrm>
-              <a:off x="7914496" y="2583293"/>
+              <a:off x="6124140" y="2583293"/>
               <a:ext cx="0" cy="3139848"/>
             </a:xfrm>
             <a:custGeom>
@@ -2959,42 +2959,85 @@
           </p:nvSpPr>
           <p:spPr>
             <a:xfrm>
-              <a:off x="1379697" y="4030394"/>
-              <a:ext cx="6892870" cy="991414"/>
+              <a:off x="7914496" y="2583293"/>
+              <a:ext cx="0" cy="3139848"/>
             </a:xfrm>
             <a:custGeom>
               <a:avLst/>
               <a:pathLst>
-                <a:path w="6892870" h="991414">
+                <a:path w="0" h="3139848">
                   <a:moveTo>
-                    <a:pt x="0" y="991414"/>
+                    <a:pt x="0" y="3139848"/>
                   </a:moveTo>
                   <a:lnTo>
-                    <a:pt x="358071" y="991414"/>
-                  </a:lnTo>
-                  <a:lnTo>
-                    <a:pt x="358071" y="803131"/>
-                  </a:lnTo>
-                  <a:lnTo>
-                    <a:pt x="984695" y="803131"/>
-                  </a:lnTo>
-                  <a:lnTo>
-                    <a:pt x="984695" y="601478"/>
-                  </a:lnTo>
-                  <a:lnTo>
-                    <a:pt x="4923478" y="601478"/>
-                  </a:lnTo>
-                  <a:lnTo>
-                    <a:pt x="4923478" y="401083"/>
-                  </a:lnTo>
-                  <a:lnTo>
-                    <a:pt x="5908174" y="401083"/>
-                  </a:lnTo>
-                  <a:lnTo>
-                    <a:pt x="5908174" y="201349"/>
-                  </a:lnTo>
-                  <a:lnTo>
-                    <a:pt x="6892870" y="201349"/>
+                    <a:pt x="0" y="0"/>
+                  </a:lnTo>
+                  <a:lnTo>
+                    <a:pt x="0" y="0"/>
+                  </a:lnTo>
+                </a:path>
+              </a:pathLst>
+            </a:custGeom>
+            <a:ln w="13550" cap="flat">
+              <a:solidFill>
+                <a:srgbClr val="EBEBEB">
+                  <a:alpha val="100000"/>
+                </a:srgbClr>
+              </a:solidFill>
+              <a:prstDash val="solid"/>
+              <a:round/>
+            </a:ln>
+          </p:spPr>
+          <p:txBody>
+            <a:bodyPr/>
+            <a:lstStyle/>
+            <a:p/>
+          </p:txBody>
+        </p:sp>
+        <p:sp>
+          <p:nvSpPr>
+            <p:cNvPr id="21" name="pl21"/>
+            <p:cNvSpPr/>
+            <p:nvPr/>
+          </p:nvSpPr>
+          <p:spPr>
+            <a:xfrm>
+              <a:off x="1379697" y="4241138"/>
+              <a:ext cx="6892870" cy="859044"/>
+            </a:xfrm>
+            <a:custGeom>
+              <a:avLst/>
+              <a:pathLst>
+                <a:path w="6892870" h="859044">
+                  <a:moveTo>
+                    <a:pt x="0" y="859044"/>
+                  </a:moveTo>
+                  <a:lnTo>
+                    <a:pt x="358071" y="859044"/>
+                  </a:lnTo>
+                  <a:lnTo>
+                    <a:pt x="358071" y="694489"/>
+                  </a:lnTo>
+                  <a:lnTo>
+                    <a:pt x="984695" y="694489"/>
+                  </a:lnTo>
+                  <a:lnTo>
+                    <a:pt x="984695" y="520349"/>
+                  </a:lnTo>
+                  <a:lnTo>
+                    <a:pt x="4923478" y="520349"/>
+                  </a:lnTo>
+                  <a:lnTo>
+                    <a:pt x="4923478" y="347028"/>
+                  </a:lnTo>
+                  <a:lnTo>
+                    <a:pt x="5908174" y="347028"/>
+                  </a:lnTo>
+                  <a:lnTo>
+                    <a:pt x="5908174" y="174760"/>
+                  </a:lnTo>
+                  <a:lnTo>
+                    <a:pt x="6892870" y="174760"/>
                   </a:lnTo>
                   <a:lnTo>
                     <a:pt x="6892870" y="0"/>
@@ -3020,48 +3063,48 @@
         </p:sp>
         <p:sp>
           <p:nvSpPr>
-            <p:cNvPr id="21" name="pl21"/>
+            <p:cNvPr id="22" name="pl22"/>
             <p:cNvSpPr/>
             <p:nvPr/>
           </p:nvSpPr>
           <p:spPr>
             <a:xfrm>
               <a:off x="1379697" y="2861938"/>
-              <a:ext cx="6892870" cy="1716572"/>
+              <a:ext cx="6892870" cy="1716082"/>
             </a:xfrm>
             <a:custGeom>
               <a:avLst/>
               <a:pathLst>
-                <a:path w="6892870" h="1716572">
+                <a:path w="6892870" h="1716082">
                   <a:moveTo>
-                    <a:pt x="0" y="1716572"/>
+                    <a:pt x="0" y="1716082"/>
                   </a:moveTo>
                   <a:lnTo>
-                    <a:pt x="358071" y="1716572"/>
-                  </a:lnTo>
-                  <a:lnTo>
-                    <a:pt x="358071" y="1384662"/>
-                  </a:lnTo>
-                  <a:lnTo>
-                    <a:pt x="984695" y="1384662"/>
-                  </a:lnTo>
-                  <a:lnTo>
-                    <a:pt x="984695" y="1032315"/>
-                  </a:lnTo>
-                  <a:lnTo>
-                    <a:pt x="4923478" y="1032315"/>
-                  </a:lnTo>
-                  <a:lnTo>
-                    <a:pt x="4923478" y="685317"/>
-                  </a:lnTo>
-                  <a:lnTo>
-                    <a:pt x="5908174" y="685317"/>
-                  </a:lnTo>
-                  <a:lnTo>
-                    <a:pt x="5908174" y="342528"/>
-                  </a:lnTo>
-                  <a:lnTo>
-                    <a:pt x="6892870" y="342528"/>
+                    <a:pt x="358071" y="1716082"/>
+                  </a:lnTo>
+                  <a:lnTo>
+                    <a:pt x="358071" y="1379804"/>
+                  </a:lnTo>
+                  <a:lnTo>
+                    <a:pt x="984695" y="1379804"/>
+                  </a:lnTo>
+                  <a:lnTo>
+                    <a:pt x="984695" y="1027878"/>
+                  </a:lnTo>
+                  <a:lnTo>
+                    <a:pt x="4923478" y="1027878"/>
+                  </a:lnTo>
+                  <a:lnTo>
+                    <a:pt x="4923478" y="681586"/>
+                  </a:lnTo>
+                  <a:lnTo>
+                    <a:pt x="5908174" y="681586"/>
+                  </a:lnTo>
+                  <a:lnTo>
+                    <a:pt x="5908174" y="341292"/>
+                  </a:lnTo>
+                  <a:lnTo>
+                    <a:pt x="6892870" y="341292"/>
                   </a:lnTo>
                   <a:lnTo>
                     <a:pt x="6892870" y="0"/>
@@ -3087,7 +3130,7 @@
         </p:sp>
         <p:sp>
           <p:nvSpPr>
-            <p:cNvPr id="22" name="tx22"/>
+            <p:cNvPr id="23" name="tx23"/>
             <p:cNvSpPr/>
             <p:nvPr/>
           </p:nvSpPr>
@@ -3133,13 +3176,13 @@
         </p:sp>
         <p:sp>
           <p:nvSpPr>
-            <p:cNvPr id="23" name="tx23"/>
+            <p:cNvPr id="24" name="tx24"/>
             <p:cNvSpPr/>
             <p:nvPr/>
           </p:nvSpPr>
           <p:spPr>
             <a:xfrm>
-              <a:off x="692708" y="4739150"/>
+              <a:off x="692708" y="4801028"/>
               <a:ext cx="279714" cy="80101"/>
             </a:xfrm>
             <a:prstGeom prst="rect">
@@ -3179,13 +3222,13 @@
         </p:sp>
         <p:sp>
           <p:nvSpPr>
-            <p:cNvPr id="24" name="tx24"/>
+            <p:cNvPr id="25" name="tx25"/>
             <p:cNvSpPr/>
             <p:nvPr/>
           </p:nvSpPr>
           <p:spPr>
             <a:xfrm>
-              <a:off x="692708" y="3937929"/>
+              <a:off x="692708" y="4061686"/>
               <a:ext cx="279714" cy="80101"/>
             </a:xfrm>
             <a:prstGeom prst="rect">
@@ -3225,13 +3268,13 @@
         </p:sp>
         <p:sp>
           <p:nvSpPr>
-            <p:cNvPr id="25" name="tx25"/>
+            <p:cNvPr id="26" name="tx26"/>
             <p:cNvSpPr/>
             <p:nvPr/>
           </p:nvSpPr>
           <p:spPr>
             <a:xfrm>
-              <a:off x="692708" y="3136708"/>
+              <a:off x="692708" y="3322343"/>
               <a:ext cx="279714" cy="80101"/>
             </a:xfrm>
             <a:prstGeom prst="rect">
@@ -3271,7 +3314,53 @@
         </p:sp>
         <p:sp>
           <p:nvSpPr>
-            <p:cNvPr id="26" name="tx26"/>
+            <p:cNvPr id="27" name="tx27"/>
+            <p:cNvSpPr/>
+            <p:nvPr/>
+          </p:nvSpPr>
+          <p:spPr>
+            <a:xfrm>
+              <a:off x="692708" y="2583000"/>
+              <a:ext cx="279714" cy="80101"/>
+            </a:xfrm>
+            <a:prstGeom prst="rect">
+              <a:avLst/>
+            </a:prstGeom>
+            <a:noFill/>
+          </p:spPr>
+          <p:txBody>
+            <a:bodyPr lIns="0" rIns="0" tIns="0" bIns="0" anchorCtr="1" anchor="ctr" wrap="none"/>
+            <a:lstStyle/>
+            <a:p>
+              <a:pPr algn="l" marL="0" marR="0" indent="0">
+                <a:lnSpc>
+                  <a:spcPts val="880"/>
+                </a:lnSpc>
+                <a:spcBef>
+                  <a:spcPts val="0"/>
+                </a:spcBef>
+                <a:spcAft>
+                  <a:spcPts val="0"/>
+                </a:spcAft>
+              </a:pPr>
+              <a:r>
+                <a:rPr sz="880">
+                  <a:solidFill>
+                    <a:srgbClr val="4D4D4D">
+                      <a:alpha val="100000"/>
+                    </a:srgbClr>
+                  </a:solidFill>
+                  <a:latin typeface="Helvetica"/>
+                  <a:cs typeface="Helvetica"/>
+                </a:rPr>
+                <a:t>0.100</a:t>
+              </a:r>
+            </a:p>
+          </p:txBody>
+        </p:sp>
+        <p:sp>
+          <p:nvSpPr>
+            <p:cNvPr id="28" name="tx28"/>
             <p:cNvSpPr/>
             <p:nvPr/>
           </p:nvSpPr>
@@ -3317,7 +3406,7 @@
         </p:sp>
         <p:sp>
           <p:nvSpPr>
-            <p:cNvPr id="27" name="tx27"/>
+            <p:cNvPr id="29" name="tx29"/>
             <p:cNvSpPr/>
             <p:nvPr/>
           </p:nvSpPr>
@@ -3363,7 +3452,7 @@
         </p:sp>
         <p:sp>
           <p:nvSpPr>
-            <p:cNvPr id="28" name="tx28"/>
+            <p:cNvPr id="30" name="tx30"/>
             <p:cNvSpPr/>
             <p:nvPr/>
           </p:nvSpPr>
@@ -3409,7 +3498,7 @@
         </p:sp>
         <p:sp>
           <p:nvSpPr>
-            <p:cNvPr id="29" name="tx29"/>
+            <p:cNvPr id="31" name="tx31"/>
             <p:cNvSpPr/>
             <p:nvPr/>
           </p:nvSpPr>
@@ -3455,7 +3544,7 @@
         </p:sp>
         <p:sp>
           <p:nvSpPr>
-            <p:cNvPr id="30" name="tx30"/>
+            <p:cNvPr id="32" name="tx32"/>
             <p:cNvSpPr/>
             <p:nvPr/>
           </p:nvSpPr>
@@ -3501,7 +3590,7 @@
         </p:sp>
         <p:sp>
           <p:nvSpPr>
-            <p:cNvPr id="31" name="tx31"/>
+            <p:cNvPr id="33" name="tx33"/>
             <p:cNvSpPr/>
             <p:nvPr/>
           </p:nvSpPr>
@@ -3547,7 +3636,7 @@
         </p:sp>
         <p:sp>
           <p:nvSpPr>
-            <p:cNvPr id="32" name="pl32"/>
+            <p:cNvPr id="34" name="pl34"/>
             <p:cNvSpPr/>
             <p:nvPr/>
           </p:nvSpPr>
@@ -3587,7 +3676,7 @@
         </p:sp>
         <p:sp>
           <p:nvSpPr>
-            <p:cNvPr id="33" name="pl33"/>
+            <p:cNvPr id="35" name="pl35"/>
             <p:cNvSpPr/>
             <p:nvPr/>
           </p:nvSpPr>
@@ -3627,7 +3716,7 @@
         </p:sp>
         <p:sp>
           <p:nvSpPr>
-            <p:cNvPr id="34" name="tx34"/>
+            <p:cNvPr id="36" name="tx36"/>
             <p:cNvSpPr/>
             <p:nvPr/>
           </p:nvSpPr>
@@ -3673,7 +3762,7 @@
         </p:sp>
         <p:sp>
           <p:nvSpPr>
-            <p:cNvPr id="35" name="tx35"/>
+            <p:cNvPr id="37" name="tx37"/>
             <p:cNvSpPr/>
             <p:nvPr/>
           </p:nvSpPr>
@@ -3719,7 +3808,7 @@
         </p:sp>
         <p:sp>
           <p:nvSpPr>
-            <p:cNvPr id="36" name="tx36"/>
+            <p:cNvPr id="38" name="tx38"/>
             <p:cNvSpPr/>
             <p:nvPr/>
           </p:nvSpPr>
@@ -3758,14 +3847,14 @@
                   <a:latin typeface="Helvetica"/>
                   <a:cs typeface="Helvetica"/>
                 </a:rPr>
-                <a:t>Discrep &gt;= +25 vs &lt;+25: subHR = 1.82 (95% CI 0.27-12.45), p = 0.543</a:t>
+                <a:t>Discrep &gt;= +25 vs &lt;+25: subHR = 2.12 (95% CI 0.45-10.06), p = 0.344</a:t>
               </a:r>
             </a:p>
           </p:txBody>
         </p:sp>
         <p:sp>
           <p:nvSpPr>
-            <p:cNvPr id="37" name="tx37"/>
+            <p:cNvPr id="39" name="tx39"/>
             <p:cNvSpPr/>
             <p:nvPr/>
           </p:nvSpPr>

</xml_diff>

<commit_message>
Use numeric ecog_score (0-5) in adjuster set, not binary ecog_score_cat2
Reverts the previous commit's switch to ecog_score_cat2 — ECOG is now
modeled as a continuous 0–5 score (1-df linear slope). All 10 adjuster
sets, caption, and descriptive paragraph updated. Output unchanged in
shape: 11 docx tables, 54 pptx plots, 0 Lapack errors, 4 small-cohort
fallbacks.

Co-Authored-By: Claude Opus 4.7 (1M context) <noreply@anthropic.com>
</commit_message>
<xml_diff>
--- a/docs/plots/carbo/jx_carbo_adjcif_aki2.pptx
+++ b/docs/plots/carbo/jx_carbo_adjcif_aki2.pptx
@@ -2271,7 +2271,7 @@
           </p:nvSpPr>
           <p:spPr>
             <a:xfrm>
-              <a:off x="1035053" y="5210750"/>
+              <a:off x="1035053" y="5179811"/>
               <a:ext cx="7582157" cy="0"/>
             </a:xfrm>
             <a:custGeom>
@@ -2314,7 +2314,7 @@
           </p:nvSpPr>
           <p:spPr>
             <a:xfrm>
-              <a:off x="1035053" y="4471408"/>
+              <a:off x="1035053" y="4378590"/>
               <a:ext cx="7582157" cy="0"/>
             </a:xfrm>
             <a:custGeom>
@@ -2357,7 +2357,7 @@
           </p:nvSpPr>
           <p:spPr>
             <a:xfrm>
-              <a:off x="1035053" y="3732065"/>
+              <a:off x="1035053" y="3577369"/>
               <a:ext cx="7582157" cy="0"/>
             </a:xfrm>
             <a:custGeom>
@@ -2400,7 +2400,7 @@
           </p:nvSpPr>
           <p:spPr>
             <a:xfrm>
-              <a:off x="1035053" y="2992722"/>
+              <a:off x="1035053" y="2776148"/>
               <a:ext cx="7582157" cy="0"/>
             </a:xfrm>
             <a:custGeom>
@@ -2658,7 +2658,7 @@
           </p:nvSpPr>
           <p:spPr>
             <a:xfrm>
-              <a:off x="1035053" y="4841079"/>
+              <a:off x="1035053" y="4779201"/>
               <a:ext cx="7582157" cy="0"/>
             </a:xfrm>
             <a:custGeom>
@@ -2701,7 +2701,7 @@
           </p:nvSpPr>
           <p:spPr>
             <a:xfrm>
-              <a:off x="1035053" y="4101736"/>
+              <a:off x="1035053" y="3977980"/>
               <a:ext cx="7582157" cy="0"/>
             </a:xfrm>
             <a:custGeom>
@@ -2744,7 +2744,7 @@
           </p:nvSpPr>
           <p:spPr>
             <a:xfrm>
-              <a:off x="1035053" y="3362394"/>
+              <a:off x="1035053" y="3176759"/>
               <a:ext cx="7582157" cy="0"/>
             </a:xfrm>
             <a:custGeom>
@@ -2787,21 +2787,21 @@
           </p:nvSpPr>
           <p:spPr>
             <a:xfrm>
-              <a:off x="1035053" y="2623051"/>
-              <a:ext cx="7582157" cy="0"/>
+              <a:off x="2543428" y="2583293"/>
+              <a:ext cx="0" cy="3139848"/>
             </a:xfrm>
             <a:custGeom>
               <a:avLst/>
               <a:pathLst>
-                <a:path w="7582157" h="0">
+                <a:path w="0" h="3139848">
                   <a:moveTo>
+                    <a:pt x="0" y="3139848"/>
+                  </a:moveTo>
+                  <a:lnTo>
                     <a:pt x="0" y="0"/>
-                  </a:moveTo>
-                  <a:lnTo>
-                    <a:pt x="7582157" y="0"/>
-                  </a:lnTo>
-                  <a:lnTo>
-                    <a:pt x="7582157" y="0"/>
+                  </a:lnTo>
+                  <a:lnTo>
+                    <a:pt x="0" y="0"/>
                   </a:lnTo>
                 </a:path>
               </a:pathLst>
@@ -2830,7 +2830,7 @@
           </p:nvSpPr>
           <p:spPr>
             <a:xfrm>
-              <a:off x="2543428" y="2583293"/>
+              <a:off x="4333784" y="2583293"/>
               <a:ext cx="0" cy="3139848"/>
             </a:xfrm>
             <a:custGeom>
@@ -2873,7 +2873,7 @@
           </p:nvSpPr>
           <p:spPr>
             <a:xfrm>
-              <a:off x="4333784" y="2583293"/>
+              <a:off x="6124140" y="2583293"/>
               <a:ext cx="0" cy="3139848"/>
             </a:xfrm>
             <a:custGeom>
@@ -2916,7 +2916,7 @@
           </p:nvSpPr>
           <p:spPr>
             <a:xfrm>
-              <a:off x="6124140" y="2583293"/>
+              <a:off x="7914496" y="2583293"/>
               <a:ext cx="0" cy="3139848"/>
             </a:xfrm>
             <a:custGeom>
@@ -2959,28 +2959,52 @@
           </p:nvSpPr>
           <p:spPr>
             <a:xfrm>
-              <a:off x="7914496" y="2583293"/>
-              <a:ext cx="0" cy="3139848"/>
+              <a:off x="1379697" y="4030394"/>
+              <a:ext cx="6892870" cy="991414"/>
             </a:xfrm>
             <a:custGeom>
               <a:avLst/>
               <a:pathLst>
-                <a:path w="0" h="3139848">
+                <a:path w="6892870" h="991414">
                   <a:moveTo>
-                    <a:pt x="0" y="3139848"/>
+                    <a:pt x="0" y="991414"/>
                   </a:moveTo>
                   <a:lnTo>
-                    <a:pt x="0" y="0"/>
-                  </a:lnTo>
-                  <a:lnTo>
-                    <a:pt x="0" y="0"/>
+                    <a:pt x="358071" y="991414"/>
+                  </a:lnTo>
+                  <a:lnTo>
+                    <a:pt x="358071" y="803131"/>
+                  </a:lnTo>
+                  <a:lnTo>
+                    <a:pt x="984695" y="803131"/>
+                  </a:lnTo>
+                  <a:lnTo>
+                    <a:pt x="984695" y="601478"/>
+                  </a:lnTo>
+                  <a:lnTo>
+                    <a:pt x="4923478" y="601478"/>
+                  </a:lnTo>
+                  <a:lnTo>
+                    <a:pt x="4923478" y="401083"/>
+                  </a:lnTo>
+                  <a:lnTo>
+                    <a:pt x="5908174" y="401083"/>
+                  </a:lnTo>
+                  <a:lnTo>
+                    <a:pt x="5908174" y="201349"/>
+                  </a:lnTo>
+                  <a:lnTo>
+                    <a:pt x="6892870" y="201349"/>
+                  </a:lnTo>
+                  <a:lnTo>
+                    <a:pt x="6892870" y="0"/>
                   </a:lnTo>
                 </a:path>
               </a:pathLst>
             </a:custGeom>
-            <a:ln w="13550" cap="flat">
+            <a:ln w="27101" cap="flat">
               <a:solidFill>
-                <a:srgbClr val="EBEBEB">
+                <a:srgbClr val="1F78B4">
                   <a:alpha val="100000"/>
                 </a:srgbClr>
               </a:solidFill>
@@ -3002,109 +3026,42 @@
           </p:nvSpPr>
           <p:spPr>
             <a:xfrm>
-              <a:off x="1379697" y="4241138"/>
-              <a:ext cx="6892870" cy="859044"/>
+              <a:off x="1379697" y="2861938"/>
+              <a:ext cx="6892870" cy="1716572"/>
             </a:xfrm>
             <a:custGeom>
               <a:avLst/>
               <a:pathLst>
-                <a:path w="6892870" h="859044">
+                <a:path w="6892870" h="1716572">
                   <a:moveTo>
-                    <a:pt x="0" y="859044"/>
+                    <a:pt x="0" y="1716572"/>
                   </a:moveTo>
                   <a:lnTo>
-                    <a:pt x="358071" y="859044"/>
-                  </a:lnTo>
-                  <a:lnTo>
-                    <a:pt x="358071" y="694489"/>
-                  </a:lnTo>
-                  <a:lnTo>
-                    <a:pt x="984695" y="694489"/>
-                  </a:lnTo>
-                  <a:lnTo>
-                    <a:pt x="984695" y="520349"/>
-                  </a:lnTo>
-                  <a:lnTo>
-                    <a:pt x="4923478" y="520349"/>
-                  </a:lnTo>
-                  <a:lnTo>
-                    <a:pt x="4923478" y="347028"/>
-                  </a:lnTo>
-                  <a:lnTo>
-                    <a:pt x="5908174" y="347028"/>
-                  </a:lnTo>
-                  <a:lnTo>
-                    <a:pt x="5908174" y="174760"/>
-                  </a:lnTo>
-                  <a:lnTo>
-                    <a:pt x="6892870" y="174760"/>
-                  </a:lnTo>
-                  <a:lnTo>
-                    <a:pt x="6892870" y="0"/>
-                  </a:lnTo>
-                </a:path>
-              </a:pathLst>
-            </a:custGeom>
-            <a:ln w="27101" cap="flat">
-              <a:solidFill>
-                <a:srgbClr val="1F78B4">
-                  <a:alpha val="100000"/>
-                </a:srgbClr>
-              </a:solidFill>
-              <a:prstDash val="solid"/>
-              <a:round/>
-            </a:ln>
-          </p:spPr>
-          <p:txBody>
-            <a:bodyPr/>
-            <a:lstStyle/>
-            <a:p/>
-          </p:txBody>
-        </p:sp>
-        <p:sp>
-          <p:nvSpPr>
-            <p:cNvPr id="22" name="pl22"/>
-            <p:cNvSpPr/>
-            <p:nvPr/>
-          </p:nvSpPr>
-          <p:spPr>
-            <a:xfrm>
-              <a:off x="1379697" y="2861938"/>
-              <a:ext cx="6892870" cy="1716082"/>
-            </a:xfrm>
-            <a:custGeom>
-              <a:avLst/>
-              <a:pathLst>
-                <a:path w="6892870" h="1716082">
-                  <a:moveTo>
-                    <a:pt x="0" y="1716082"/>
-                  </a:moveTo>
-                  <a:lnTo>
-                    <a:pt x="358071" y="1716082"/>
-                  </a:lnTo>
-                  <a:lnTo>
-                    <a:pt x="358071" y="1379804"/>
-                  </a:lnTo>
-                  <a:lnTo>
-                    <a:pt x="984695" y="1379804"/>
-                  </a:lnTo>
-                  <a:lnTo>
-                    <a:pt x="984695" y="1027878"/>
-                  </a:lnTo>
-                  <a:lnTo>
-                    <a:pt x="4923478" y="1027878"/>
-                  </a:lnTo>
-                  <a:lnTo>
-                    <a:pt x="4923478" y="681586"/>
-                  </a:lnTo>
-                  <a:lnTo>
-                    <a:pt x="5908174" y="681586"/>
-                  </a:lnTo>
-                  <a:lnTo>
-                    <a:pt x="5908174" y="341292"/>
-                  </a:lnTo>
-                  <a:lnTo>
-                    <a:pt x="6892870" y="341292"/>
+                    <a:pt x="358071" y="1716572"/>
+                  </a:lnTo>
+                  <a:lnTo>
+                    <a:pt x="358071" y="1384662"/>
+                  </a:lnTo>
+                  <a:lnTo>
+                    <a:pt x="984695" y="1384662"/>
+                  </a:lnTo>
+                  <a:lnTo>
+                    <a:pt x="984695" y="1032315"/>
+                  </a:lnTo>
+                  <a:lnTo>
+                    <a:pt x="4923478" y="1032315"/>
+                  </a:lnTo>
+                  <a:lnTo>
+                    <a:pt x="4923478" y="685317"/>
+                  </a:lnTo>
+                  <a:lnTo>
+                    <a:pt x="5908174" y="685317"/>
+                  </a:lnTo>
+                  <a:lnTo>
+                    <a:pt x="5908174" y="342528"/>
+                  </a:lnTo>
+                  <a:lnTo>
+                    <a:pt x="6892870" y="342528"/>
                   </a:lnTo>
                   <a:lnTo>
                     <a:pt x="6892870" y="0"/>
@@ -3130,7 +3087,7 @@
         </p:sp>
         <p:sp>
           <p:nvSpPr>
-            <p:cNvPr id="23" name="tx23"/>
+            <p:cNvPr id="22" name="tx22"/>
             <p:cNvSpPr/>
             <p:nvPr/>
           </p:nvSpPr>
@@ -3176,13 +3133,13 @@
         </p:sp>
         <p:sp>
           <p:nvSpPr>
-            <p:cNvPr id="24" name="tx24"/>
+            <p:cNvPr id="23" name="tx23"/>
             <p:cNvSpPr/>
             <p:nvPr/>
           </p:nvSpPr>
           <p:spPr>
             <a:xfrm>
-              <a:off x="692708" y="4801028"/>
+              <a:off x="692708" y="4739150"/>
               <a:ext cx="279714" cy="80101"/>
             </a:xfrm>
             <a:prstGeom prst="rect">
@@ -3222,13 +3179,13 @@
         </p:sp>
         <p:sp>
           <p:nvSpPr>
-            <p:cNvPr id="25" name="tx25"/>
+            <p:cNvPr id="24" name="tx24"/>
             <p:cNvSpPr/>
             <p:nvPr/>
           </p:nvSpPr>
           <p:spPr>
             <a:xfrm>
-              <a:off x="692708" y="4061686"/>
+              <a:off x="692708" y="3937929"/>
               <a:ext cx="279714" cy="80101"/>
             </a:xfrm>
             <a:prstGeom prst="rect">
@@ -3268,13 +3225,13 @@
         </p:sp>
         <p:sp>
           <p:nvSpPr>
-            <p:cNvPr id="26" name="tx26"/>
+            <p:cNvPr id="25" name="tx25"/>
             <p:cNvSpPr/>
             <p:nvPr/>
           </p:nvSpPr>
           <p:spPr>
             <a:xfrm>
-              <a:off x="692708" y="3322343"/>
+              <a:off x="692708" y="3136708"/>
               <a:ext cx="279714" cy="80101"/>
             </a:xfrm>
             <a:prstGeom prst="rect">
@@ -3314,53 +3271,7 @@
         </p:sp>
         <p:sp>
           <p:nvSpPr>
-            <p:cNvPr id="27" name="tx27"/>
-            <p:cNvSpPr/>
-            <p:nvPr/>
-          </p:nvSpPr>
-          <p:spPr>
-            <a:xfrm>
-              <a:off x="692708" y="2583000"/>
-              <a:ext cx="279714" cy="80101"/>
-            </a:xfrm>
-            <a:prstGeom prst="rect">
-              <a:avLst/>
-            </a:prstGeom>
-            <a:noFill/>
-          </p:spPr>
-          <p:txBody>
-            <a:bodyPr lIns="0" rIns="0" tIns="0" bIns="0" anchorCtr="1" anchor="ctr" wrap="none"/>
-            <a:lstStyle/>
-            <a:p>
-              <a:pPr algn="l" marL="0" marR="0" indent="0">
-                <a:lnSpc>
-                  <a:spcPts val="880"/>
-                </a:lnSpc>
-                <a:spcBef>
-                  <a:spcPts val="0"/>
-                </a:spcBef>
-                <a:spcAft>
-                  <a:spcPts val="0"/>
-                </a:spcAft>
-              </a:pPr>
-              <a:r>
-                <a:rPr sz="880">
-                  <a:solidFill>
-                    <a:srgbClr val="4D4D4D">
-                      <a:alpha val="100000"/>
-                    </a:srgbClr>
-                  </a:solidFill>
-                  <a:latin typeface="Helvetica"/>
-                  <a:cs typeface="Helvetica"/>
-                </a:rPr>
-                <a:t>0.100</a:t>
-              </a:r>
-            </a:p>
-          </p:txBody>
-        </p:sp>
-        <p:sp>
-          <p:nvSpPr>
-            <p:cNvPr id="28" name="tx28"/>
+            <p:cNvPr id="26" name="tx26"/>
             <p:cNvSpPr/>
             <p:nvPr/>
           </p:nvSpPr>
@@ -3406,7 +3317,7 @@
         </p:sp>
         <p:sp>
           <p:nvSpPr>
-            <p:cNvPr id="29" name="tx29"/>
+            <p:cNvPr id="27" name="tx27"/>
             <p:cNvSpPr/>
             <p:nvPr/>
           </p:nvSpPr>
@@ -3452,7 +3363,7 @@
         </p:sp>
         <p:sp>
           <p:nvSpPr>
-            <p:cNvPr id="30" name="tx30"/>
+            <p:cNvPr id="28" name="tx28"/>
             <p:cNvSpPr/>
             <p:nvPr/>
           </p:nvSpPr>
@@ -3498,7 +3409,7 @@
         </p:sp>
         <p:sp>
           <p:nvSpPr>
-            <p:cNvPr id="31" name="tx31"/>
+            <p:cNvPr id="29" name="tx29"/>
             <p:cNvSpPr/>
             <p:nvPr/>
           </p:nvSpPr>
@@ -3544,7 +3455,7 @@
         </p:sp>
         <p:sp>
           <p:nvSpPr>
-            <p:cNvPr id="32" name="tx32"/>
+            <p:cNvPr id="30" name="tx30"/>
             <p:cNvSpPr/>
             <p:nvPr/>
           </p:nvSpPr>
@@ -3590,7 +3501,7 @@
         </p:sp>
         <p:sp>
           <p:nvSpPr>
-            <p:cNvPr id="33" name="tx33"/>
+            <p:cNvPr id="31" name="tx31"/>
             <p:cNvSpPr/>
             <p:nvPr/>
           </p:nvSpPr>
@@ -3636,7 +3547,7 @@
         </p:sp>
         <p:sp>
           <p:nvSpPr>
-            <p:cNvPr id="34" name="pl34"/>
+            <p:cNvPr id="32" name="pl32"/>
             <p:cNvSpPr/>
             <p:nvPr/>
           </p:nvSpPr>
@@ -3676,7 +3587,7 @@
         </p:sp>
         <p:sp>
           <p:nvSpPr>
-            <p:cNvPr id="35" name="pl35"/>
+            <p:cNvPr id="33" name="pl33"/>
             <p:cNvSpPr/>
             <p:nvPr/>
           </p:nvSpPr>
@@ -3716,7 +3627,7 @@
         </p:sp>
         <p:sp>
           <p:nvSpPr>
-            <p:cNvPr id="36" name="tx36"/>
+            <p:cNvPr id="34" name="tx34"/>
             <p:cNvSpPr/>
             <p:nvPr/>
           </p:nvSpPr>
@@ -3762,7 +3673,7 @@
         </p:sp>
         <p:sp>
           <p:nvSpPr>
-            <p:cNvPr id="37" name="tx37"/>
+            <p:cNvPr id="35" name="tx35"/>
             <p:cNvSpPr/>
             <p:nvPr/>
           </p:nvSpPr>
@@ -3808,7 +3719,7 @@
         </p:sp>
         <p:sp>
           <p:nvSpPr>
-            <p:cNvPr id="38" name="tx38"/>
+            <p:cNvPr id="36" name="tx36"/>
             <p:cNvSpPr/>
             <p:nvPr/>
           </p:nvSpPr>
@@ -3847,14 +3758,14 @@
                   <a:latin typeface="Helvetica"/>
                   <a:cs typeface="Helvetica"/>
                 </a:rPr>
-                <a:t>Discrep &gt;= +25 vs &lt;+25: subHR = 2.12 (95% CI 0.45-10.06), p = 0.344</a:t>
+                <a:t>Discrep &gt;= +25 vs &lt;+25: subHR = 1.82 (95% CI 0.27-12.45), p = 0.543</a:t>
               </a:r>
             </a:p>
           </p:txBody>
         </p:sp>
         <p:sp>
           <p:nvSpPr>
-            <p:cNvPr id="39" name="tx39"/>
+            <p:cNvPr id="37" name="tx37"/>
             <p:cNvSpPr/>
             <p:nvPr/>
           </p:nvSpPr>

</xml_diff>

<commit_message>
Table 1 age now median/IQR; larger axis labels on every plot
- sherley_carbo.qmd Table 1: age summary statistic flipped from
  "{mean} ({sd})" → "{median} ({p25}, {p75})". Renders as
  "70 (63, 76)" for the carbo cohort.
- All plot helpers (plot_subhr_*, plot_cox_*, adj_cif,
  adj_death_curve, .plot_failed) plus the inline histograms now use
  theme_minimal(base_size = 14) — up from 11. Axis titles and tick
  text scale up proportionally for both the rendered PNGs and the
  editable PowerPoint downloads. Subtitle override bumped 9 → 12 to
  keep proportions with the new base.

Re-render verified: 11/11 docx tables, 54/54 pptx slides, 0 Lapack
errors, 4 unchanged fallback placeholders.

Co-Authored-By: Claude Opus 4.7 (1M context) <noreply@anthropic.com>
</commit_message>
<xml_diff>
--- a/docs/plots/carbo/jx_carbo_adjcif_aki2.pptx
+++ b/docs/plots/carbo/jx_carbo_adjcif_aki2.pptx
@@ -2271,26 +2271,26 @@
           </p:nvSpPr>
           <p:spPr>
             <a:xfrm>
-              <a:off x="1035053" y="5179811"/>
-              <a:ext cx="7582157" cy="0"/>
+              <a:off x="1192159" y="5123525"/>
+              <a:ext cx="7406072" cy="0"/>
             </a:xfrm>
             <a:custGeom>
               <a:avLst/>
               <a:pathLst>
-                <a:path w="7582157" h="0">
+                <a:path w="7406072" h="0">
                   <a:moveTo>
                     <a:pt x="0" y="0"/>
                   </a:moveTo>
                   <a:lnTo>
-                    <a:pt x="7582157" y="0"/>
-                  </a:lnTo>
-                  <a:lnTo>
-                    <a:pt x="7582157" y="0"/>
+                    <a:pt x="7406072" y="0"/>
+                  </a:lnTo>
+                  <a:lnTo>
+                    <a:pt x="7406072" y="0"/>
                   </a:lnTo>
                 </a:path>
               </a:pathLst>
             </a:custGeom>
-            <a:ln w="6775" cap="flat">
+            <a:ln w="8623" cap="flat">
               <a:solidFill>
                 <a:srgbClr val="EBEBEB">
                   <a:alpha val="100000"/>
@@ -2314,26 +2314,26 @@
           </p:nvSpPr>
           <p:spPr>
             <a:xfrm>
-              <a:off x="1035053" y="4378590"/>
-              <a:ext cx="7582157" cy="0"/>
+              <a:off x="1192159" y="4401265"/>
+              <a:ext cx="7406072" cy="0"/>
             </a:xfrm>
             <a:custGeom>
               <a:avLst/>
               <a:pathLst>
-                <a:path w="7582157" h="0">
+                <a:path w="7406072" h="0">
                   <a:moveTo>
                     <a:pt x="0" y="0"/>
                   </a:moveTo>
                   <a:lnTo>
-                    <a:pt x="7582157" y="0"/>
-                  </a:lnTo>
-                  <a:lnTo>
-                    <a:pt x="7582157" y="0"/>
+                    <a:pt x="7406072" y="0"/>
+                  </a:lnTo>
+                  <a:lnTo>
+                    <a:pt x="7406072" y="0"/>
                   </a:lnTo>
                 </a:path>
               </a:pathLst>
             </a:custGeom>
-            <a:ln w="6775" cap="flat">
+            <a:ln w="8623" cap="flat">
               <a:solidFill>
                 <a:srgbClr val="EBEBEB">
                   <a:alpha val="100000"/>
@@ -2357,26 +2357,26 @@
           </p:nvSpPr>
           <p:spPr>
             <a:xfrm>
-              <a:off x="1035053" y="3577369"/>
-              <a:ext cx="7582157" cy="0"/>
+              <a:off x="1192159" y="3679005"/>
+              <a:ext cx="7406072" cy="0"/>
             </a:xfrm>
             <a:custGeom>
               <a:avLst/>
               <a:pathLst>
-                <a:path w="7582157" h="0">
+                <a:path w="7406072" h="0">
                   <a:moveTo>
                     <a:pt x="0" y="0"/>
                   </a:moveTo>
                   <a:lnTo>
-                    <a:pt x="7582157" y="0"/>
-                  </a:lnTo>
-                  <a:lnTo>
-                    <a:pt x="7582157" y="0"/>
+                    <a:pt x="7406072" y="0"/>
+                  </a:lnTo>
+                  <a:lnTo>
+                    <a:pt x="7406072" y="0"/>
                   </a:lnTo>
                 </a:path>
               </a:pathLst>
             </a:custGeom>
-            <a:ln w="6775" cap="flat">
+            <a:ln w="8623" cap="flat">
               <a:solidFill>
                 <a:srgbClr val="EBEBEB">
                   <a:alpha val="100000"/>
@@ -2400,26 +2400,26 @@
           </p:nvSpPr>
           <p:spPr>
             <a:xfrm>
-              <a:off x="1035053" y="2776148"/>
-              <a:ext cx="7582157" cy="0"/>
+              <a:off x="1192159" y="2956745"/>
+              <a:ext cx="7406072" cy="0"/>
             </a:xfrm>
             <a:custGeom>
               <a:avLst/>
               <a:pathLst>
-                <a:path w="7582157" h="0">
+                <a:path w="7406072" h="0">
                   <a:moveTo>
                     <a:pt x="0" y="0"/>
                   </a:moveTo>
                   <a:lnTo>
-                    <a:pt x="7582157" y="0"/>
-                  </a:lnTo>
-                  <a:lnTo>
-                    <a:pt x="7582157" y="0"/>
+                    <a:pt x="7406072" y="0"/>
+                  </a:lnTo>
+                  <a:lnTo>
+                    <a:pt x="7406072" y="0"/>
                   </a:lnTo>
                 </a:path>
               </a:pathLst>
             </a:custGeom>
-            <a:ln w="6775" cap="flat">
+            <a:ln w="8623" cap="flat">
               <a:solidFill>
                 <a:srgbClr val="EBEBEB">
                   <a:alpha val="100000"/>
@@ -2443,15 +2443,15 @@
           </p:nvSpPr>
           <p:spPr>
             <a:xfrm>
-              <a:off x="1648250" y="2583293"/>
-              <a:ext cx="0" cy="3139848"/>
+              <a:off x="1791115" y="2782896"/>
+              <a:ext cx="0" cy="2830414"/>
             </a:xfrm>
             <a:custGeom>
               <a:avLst/>
               <a:pathLst>
-                <a:path w="0" h="3139848">
+                <a:path w="0" h="2830414">
                   <a:moveTo>
-                    <a:pt x="0" y="3139848"/>
+                    <a:pt x="0" y="2830414"/>
                   </a:moveTo>
                   <a:lnTo>
                     <a:pt x="0" y="0"/>
@@ -2462,7 +2462,7 @@
                 </a:path>
               </a:pathLst>
             </a:custGeom>
-            <a:ln w="6775" cap="flat">
+            <a:ln w="8623" cap="flat">
               <a:solidFill>
                 <a:srgbClr val="EBEBEB">
                   <a:alpha val="100000"/>
@@ -2486,15 +2486,15 @@
           </p:nvSpPr>
           <p:spPr>
             <a:xfrm>
-              <a:off x="3438606" y="2583293"/>
-              <a:ext cx="0" cy="3139848"/>
+              <a:off x="3539893" y="2782896"/>
+              <a:ext cx="0" cy="2830414"/>
             </a:xfrm>
             <a:custGeom>
               <a:avLst/>
               <a:pathLst>
-                <a:path w="0" h="3139848">
+                <a:path w="0" h="2830414">
                   <a:moveTo>
-                    <a:pt x="0" y="3139848"/>
+                    <a:pt x="0" y="2830414"/>
                   </a:moveTo>
                   <a:lnTo>
                     <a:pt x="0" y="0"/>
@@ -2505,7 +2505,7 @@
                 </a:path>
               </a:pathLst>
             </a:custGeom>
-            <a:ln w="6775" cap="flat">
+            <a:ln w="8623" cap="flat">
               <a:solidFill>
                 <a:srgbClr val="EBEBEB">
                   <a:alpha val="100000"/>
@@ -2529,15 +2529,15 @@
           </p:nvSpPr>
           <p:spPr>
             <a:xfrm>
-              <a:off x="5228962" y="2583293"/>
-              <a:ext cx="0" cy="3139848"/>
+              <a:off x="5288670" y="2782896"/>
+              <a:ext cx="0" cy="2830414"/>
             </a:xfrm>
             <a:custGeom>
               <a:avLst/>
               <a:pathLst>
-                <a:path w="0" h="3139848">
+                <a:path w="0" h="2830414">
                   <a:moveTo>
-                    <a:pt x="0" y="3139848"/>
+                    <a:pt x="0" y="2830414"/>
                   </a:moveTo>
                   <a:lnTo>
                     <a:pt x="0" y="0"/>
@@ -2548,7 +2548,7 @@
                 </a:path>
               </a:pathLst>
             </a:custGeom>
-            <a:ln w="6775" cap="flat">
+            <a:ln w="8623" cap="flat">
               <a:solidFill>
                 <a:srgbClr val="EBEBEB">
                   <a:alpha val="100000"/>
@@ -2572,15 +2572,15 @@
           </p:nvSpPr>
           <p:spPr>
             <a:xfrm>
-              <a:off x="7019318" y="2583293"/>
-              <a:ext cx="0" cy="3139848"/>
+              <a:off x="7037448" y="2782896"/>
+              <a:ext cx="0" cy="2830414"/>
             </a:xfrm>
             <a:custGeom>
               <a:avLst/>
               <a:pathLst>
-                <a:path w="0" h="3139848">
+                <a:path w="0" h="2830414">
                   <a:moveTo>
-                    <a:pt x="0" y="3139848"/>
+                    <a:pt x="0" y="2830414"/>
                   </a:moveTo>
                   <a:lnTo>
                     <a:pt x="0" y="0"/>
@@ -2591,7 +2591,7 @@
                 </a:path>
               </a:pathLst>
             </a:custGeom>
-            <a:ln w="6775" cap="flat">
+            <a:ln w="8623" cap="flat">
               <a:solidFill>
                 <a:srgbClr val="EBEBEB">
                   <a:alpha val="100000"/>
@@ -2615,26 +2615,26 @@
           </p:nvSpPr>
           <p:spPr>
             <a:xfrm>
-              <a:off x="1035053" y="5580422"/>
-              <a:ext cx="7582157" cy="0"/>
+              <a:off x="1192159" y="5484655"/>
+              <a:ext cx="7406072" cy="0"/>
             </a:xfrm>
             <a:custGeom>
               <a:avLst/>
               <a:pathLst>
-                <a:path w="7582157" h="0">
+                <a:path w="7406072" h="0">
                   <a:moveTo>
                     <a:pt x="0" y="0"/>
                   </a:moveTo>
                   <a:lnTo>
-                    <a:pt x="7582157" y="0"/>
-                  </a:lnTo>
-                  <a:lnTo>
-                    <a:pt x="7582157" y="0"/>
+                    <a:pt x="7406072" y="0"/>
+                  </a:lnTo>
+                  <a:lnTo>
+                    <a:pt x="7406072" y="0"/>
                   </a:lnTo>
                 </a:path>
               </a:pathLst>
             </a:custGeom>
-            <a:ln w="13550" cap="flat">
+            <a:ln w="17246" cap="flat">
               <a:solidFill>
                 <a:srgbClr val="EBEBEB">
                   <a:alpha val="100000"/>
@@ -2658,26 +2658,26 @@
           </p:nvSpPr>
           <p:spPr>
             <a:xfrm>
-              <a:off x="1035053" y="4779201"/>
-              <a:ext cx="7582157" cy="0"/>
+              <a:off x="1192159" y="4762395"/>
+              <a:ext cx="7406072" cy="0"/>
             </a:xfrm>
             <a:custGeom>
               <a:avLst/>
               <a:pathLst>
-                <a:path w="7582157" h="0">
+                <a:path w="7406072" h="0">
                   <a:moveTo>
                     <a:pt x="0" y="0"/>
                   </a:moveTo>
                   <a:lnTo>
-                    <a:pt x="7582157" y="0"/>
-                  </a:lnTo>
-                  <a:lnTo>
-                    <a:pt x="7582157" y="0"/>
+                    <a:pt x="7406072" y="0"/>
+                  </a:lnTo>
+                  <a:lnTo>
+                    <a:pt x="7406072" y="0"/>
                   </a:lnTo>
                 </a:path>
               </a:pathLst>
             </a:custGeom>
-            <a:ln w="13550" cap="flat">
+            <a:ln w="17246" cap="flat">
               <a:solidFill>
                 <a:srgbClr val="EBEBEB">
                   <a:alpha val="100000"/>
@@ -2701,26 +2701,26 @@
           </p:nvSpPr>
           <p:spPr>
             <a:xfrm>
-              <a:off x="1035053" y="3977980"/>
-              <a:ext cx="7582157" cy="0"/>
+              <a:off x="1192159" y="4040135"/>
+              <a:ext cx="7406072" cy="0"/>
             </a:xfrm>
             <a:custGeom>
               <a:avLst/>
               <a:pathLst>
-                <a:path w="7582157" h="0">
+                <a:path w="7406072" h="0">
                   <a:moveTo>
                     <a:pt x="0" y="0"/>
                   </a:moveTo>
                   <a:lnTo>
-                    <a:pt x="7582157" y="0"/>
-                  </a:lnTo>
-                  <a:lnTo>
-                    <a:pt x="7582157" y="0"/>
+                    <a:pt x="7406072" y="0"/>
+                  </a:lnTo>
+                  <a:lnTo>
+                    <a:pt x="7406072" y="0"/>
                   </a:lnTo>
                 </a:path>
               </a:pathLst>
             </a:custGeom>
-            <a:ln w="13550" cap="flat">
+            <a:ln w="17246" cap="flat">
               <a:solidFill>
                 <a:srgbClr val="EBEBEB">
                   <a:alpha val="100000"/>
@@ -2744,26 +2744,26 @@
           </p:nvSpPr>
           <p:spPr>
             <a:xfrm>
-              <a:off x="1035053" y="3176759"/>
-              <a:ext cx="7582157" cy="0"/>
+              <a:off x="1192159" y="3317875"/>
+              <a:ext cx="7406072" cy="0"/>
             </a:xfrm>
             <a:custGeom>
               <a:avLst/>
               <a:pathLst>
-                <a:path w="7582157" h="0">
+                <a:path w="7406072" h="0">
                   <a:moveTo>
                     <a:pt x="0" y="0"/>
                   </a:moveTo>
                   <a:lnTo>
-                    <a:pt x="7582157" y="0"/>
-                  </a:lnTo>
-                  <a:lnTo>
-                    <a:pt x="7582157" y="0"/>
+                    <a:pt x="7406072" y="0"/>
+                  </a:lnTo>
+                  <a:lnTo>
+                    <a:pt x="7406072" y="0"/>
                   </a:lnTo>
                 </a:path>
               </a:pathLst>
             </a:custGeom>
-            <a:ln w="13550" cap="flat">
+            <a:ln w="17246" cap="flat">
               <a:solidFill>
                 <a:srgbClr val="EBEBEB">
                   <a:alpha val="100000"/>
@@ -2787,15 +2787,15 @@
           </p:nvSpPr>
           <p:spPr>
             <a:xfrm>
-              <a:off x="2543428" y="2583293"/>
-              <a:ext cx="0" cy="3139848"/>
+              <a:off x="2665504" y="2782896"/>
+              <a:ext cx="0" cy="2830414"/>
             </a:xfrm>
             <a:custGeom>
               <a:avLst/>
               <a:pathLst>
-                <a:path w="0" h="3139848">
+                <a:path w="0" h="2830414">
                   <a:moveTo>
-                    <a:pt x="0" y="3139848"/>
+                    <a:pt x="0" y="2830414"/>
                   </a:moveTo>
                   <a:lnTo>
                     <a:pt x="0" y="0"/>
@@ -2806,7 +2806,7 @@
                 </a:path>
               </a:pathLst>
             </a:custGeom>
-            <a:ln w="13550" cap="flat">
+            <a:ln w="17246" cap="flat">
               <a:solidFill>
                 <a:srgbClr val="EBEBEB">
                   <a:alpha val="100000"/>
@@ -2830,15 +2830,15 @@
           </p:nvSpPr>
           <p:spPr>
             <a:xfrm>
-              <a:off x="4333784" y="2583293"/>
-              <a:ext cx="0" cy="3139848"/>
+              <a:off x="4414282" y="2782896"/>
+              <a:ext cx="0" cy="2830414"/>
             </a:xfrm>
             <a:custGeom>
               <a:avLst/>
               <a:pathLst>
-                <a:path w="0" h="3139848">
+                <a:path w="0" h="2830414">
                   <a:moveTo>
-                    <a:pt x="0" y="3139848"/>
+                    <a:pt x="0" y="2830414"/>
                   </a:moveTo>
                   <a:lnTo>
                     <a:pt x="0" y="0"/>
@@ -2849,7 +2849,7 @@
                 </a:path>
               </a:pathLst>
             </a:custGeom>
-            <a:ln w="13550" cap="flat">
+            <a:ln w="17246" cap="flat">
               <a:solidFill>
                 <a:srgbClr val="EBEBEB">
                   <a:alpha val="100000"/>
@@ -2873,15 +2873,15 @@
           </p:nvSpPr>
           <p:spPr>
             <a:xfrm>
-              <a:off x="6124140" y="2583293"/>
-              <a:ext cx="0" cy="3139848"/>
+              <a:off x="6163059" y="2782896"/>
+              <a:ext cx="0" cy="2830414"/>
             </a:xfrm>
             <a:custGeom>
               <a:avLst/>
               <a:pathLst>
-                <a:path w="0" h="3139848">
+                <a:path w="0" h="2830414">
                   <a:moveTo>
-                    <a:pt x="0" y="3139848"/>
+                    <a:pt x="0" y="2830414"/>
                   </a:moveTo>
                   <a:lnTo>
                     <a:pt x="0" y="0"/>
@@ -2892,7 +2892,7 @@
                 </a:path>
               </a:pathLst>
             </a:custGeom>
-            <a:ln w="13550" cap="flat">
+            <a:ln w="17246" cap="flat">
               <a:solidFill>
                 <a:srgbClr val="EBEBEB">
                   <a:alpha val="100000"/>
@@ -2916,15 +2916,15 @@
           </p:nvSpPr>
           <p:spPr>
             <a:xfrm>
-              <a:off x="7914496" y="2583293"/>
-              <a:ext cx="0" cy="3139848"/>
+              <a:off x="7911836" y="2782896"/>
+              <a:ext cx="0" cy="2830414"/>
             </a:xfrm>
             <a:custGeom>
               <a:avLst/>
               <a:pathLst>
-                <a:path w="0" h="3139848">
+                <a:path w="0" h="2830414">
                   <a:moveTo>
-                    <a:pt x="0" y="3139848"/>
+                    <a:pt x="0" y="2830414"/>
                   </a:moveTo>
                   <a:lnTo>
                     <a:pt x="0" y="0"/>
@@ -2935,7 +2935,7 @@
                 </a:path>
               </a:pathLst>
             </a:custGeom>
-            <a:ln w="13550" cap="flat">
+            <a:ln w="17246" cap="flat">
               <a:solidFill>
                 <a:srgbClr val="EBEBEB">
                   <a:alpha val="100000"/>
@@ -2959,45 +2959,45 @@
           </p:nvSpPr>
           <p:spPr>
             <a:xfrm>
-              <a:off x="1379697" y="4030394"/>
-              <a:ext cx="6892870" cy="991414"/>
+              <a:off x="1528799" y="4087384"/>
+              <a:ext cx="6732793" cy="893709"/>
             </a:xfrm>
             <a:custGeom>
               <a:avLst/>
               <a:pathLst>
-                <a:path w="6892870" h="991414">
+                <a:path w="6732793" h="893709">
                   <a:moveTo>
-                    <a:pt x="0" y="991414"/>
+                    <a:pt x="0" y="893709"/>
                   </a:moveTo>
                   <a:lnTo>
-                    <a:pt x="358071" y="991414"/>
-                  </a:lnTo>
-                  <a:lnTo>
-                    <a:pt x="358071" y="803132"/>
-                  </a:lnTo>
-                  <a:lnTo>
-                    <a:pt x="984695" y="803132"/>
-                  </a:lnTo>
-                  <a:lnTo>
-                    <a:pt x="984695" y="601478"/>
-                  </a:lnTo>
-                  <a:lnTo>
-                    <a:pt x="4923478" y="601478"/>
-                  </a:lnTo>
-                  <a:lnTo>
-                    <a:pt x="4923478" y="401083"/>
-                  </a:lnTo>
-                  <a:lnTo>
-                    <a:pt x="5908174" y="401083"/>
-                  </a:lnTo>
-                  <a:lnTo>
-                    <a:pt x="5908174" y="201349"/>
-                  </a:lnTo>
-                  <a:lnTo>
-                    <a:pt x="6892870" y="201349"/>
-                  </a:lnTo>
-                  <a:lnTo>
-                    <a:pt x="6892870" y="0"/>
+                    <a:pt x="349755" y="893709"/>
+                  </a:lnTo>
+                  <a:lnTo>
+                    <a:pt x="349755" y="723982"/>
+                  </a:lnTo>
+                  <a:lnTo>
+                    <a:pt x="961827" y="723982"/>
+                  </a:lnTo>
+                  <a:lnTo>
+                    <a:pt x="961827" y="542202"/>
+                  </a:lnTo>
+                  <a:lnTo>
+                    <a:pt x="4809138" y="542202"/>
+                  </a:lnTo>
+                  <a:lnTo>
+                    <a:pt x="4809138" y="361556"/>
+                  </a:lnTo>
+                  <a:lnTo>
+                    <a:pt x="5770965" y="361556"/>
+                  </a:lnTo>
+                  <a:lnTo>
+                    <a:pt x="5770965" y="181506"/>
+                  </a:lnTo>
+                  <a:lnTo>
+                    <a:pt x="6732793" y="181506"/>
+                  </a:lnTo>
+                  <a:lnTo>
+                    <a:pt x="6732793" y="0"/>
                   </a:lnTo>
                 </a:path>
               </a:pathLst>
@@ -3026,45 +3026,45 @@
           </p:nvSpPr>
           <p:spPr>
             <a:xfrm>
-              <a:off x="1379697" y="2861938"/>
-              <a:ext cx="6892870" cy="1716572"/>
+              <a:off x="1528799" y="3034080"/>
+              <a:ext cx="6732793" cy="1547403"/>
             </a:xfrm>
             <a:custGeom>
               <a:avLst/>
               <a:pathLst>
-                <a:path w="6892870" h="1716572">
+                <a:path w="6732793" h="1547403">
                   <a:moveTo>
-                    <a:pt x="0" y="1716572"/>
+                    <a:pt x="0" y="1547403"/>
                   </a:moveTo>
                   <a:lnTo>
-                    <a:pt x="358071" y="1716572"/>
-                  </a:lnTo>
-                  <a:lnTo>
-                    <a:pt x="358071" y="1384662"/>
-                  </a:lnTo>
-                  <a:lnTo>
-                    <a:pt x="984695" y="1384662"/>
-                  </a:lnTo>
-                  <a:lnTo>
-                    <a:pt x="984695" y="1032315"/>
-                  </a:lnTo>
-                  <a:lnTo>
-                    <a:pt x="4923478" y="1032315"/>
-                  </a:lnTo>
-                  <a:lnTo>
-                    <a:pt x="4923478" y="685317"/>
-                  </a:lnTo>
-                  <a:lnTo>
-                    <a:pt x="5908174" y="685317"/>
-                  </a:lnTo>
-                  <a:lnTo>
-                    <a:pt x="5908174" y="342528"/>
-                  </a:lnTo>
-                  <a:lnTo>
-                    <a:pt x="6892870" y="342528"/>
-                  </a:lnTo>
-                  <a:lnTo>
-                    <a:pt x="6892870" y="0"/>
+                    <a:pt x="349755" y="1547403"/>
+                  </a:lnTo>
+                  <a:lnTo>
+                    <a:pt x="349755" y="1248203"/>
+                  </a:lnTo>
+                  <a:lnTo>
+                    <a:pt x="961827" y="1248203"/>
+                  </a:lnTo>
+                  <a:lnTo>
+                    <a:pt x="961827" y="930580"/>
+                  </a:lnTo>
+                  <a:lnTo>
+                    <a:pt x="4809138" y="930580"/>
+                  </a:lnTo>
+                  <a:lnTo>
+                    <a:pt x="4809138" y="617779"/>
+                  </a:lnTo>
+                  <a:lnTo>
+                    <a:pt x="5770965" y="617779"/>
+                  </a:lnTo>
+                  <a:lnTo>
+                    <a:pt x="5770965" y="308772"/>
+                  </a:lnTo>
+                  <a:lnTo>
+                    <a:pt x="6732793" y="308772"/>
+                  </a:lnTo>
+                  <a:lnTo>
+                    <a:pt x="6732793" y="0"/>
                   </a:lnTo>
                 </a:path>
               </a:pathLst>
@@ -3093,8 +3093,8 @@
           </p:nvSpPr>
           <p:spPr>
             <a:xfrm>
-              <a:off x="692708" y="5540371"/>
-              <a:ext cx="279714" cy="80101"/>
+              <a:off x="756929" y="5433678"/>
+              <a:ext cx="355518" cy="101955"/>
             </a:xfrm>
             <a:prstGeom prst="rect">
               <a:avLst/>
@@ -3107,7 +3107,7 @@
             <a:p>
               <a:pPr algn="l" marL="0" marR="0" indent="0">
                 <a:lnSpc>
-                  <a:spcPts val="880"/>
+                  <a:spcPts val="1120"/>
                 </a:lnSpc>
                 <a:spcBef>
                   <a:spcPts val="0"/>
@@ -3117,7 +3117,7 @@
                 </a:spcAft>
               </a:pPr>
               <a:r>
-                <a:rPr sz="880">
+                <a:rPr sz="1120">
                   <a:solidFill>
                     <a:srgbClr val="4D4D4D">
                       <a:alpha val="100000"/>
@@ -3139,8 +3139,8 @@
           </p:nvSpPr>
           <p:spPr>
             <a:xfrm>
-              <a:off x="692708" y="4739150"/>
-              <a:ext cx="279714" cy="80101"/>
+              <a:off x="756929" y="4711418"/>
+              <a:ext cx="355518" cy="101955"/>
             </a:xfrm>
             <a:prstGeom prst="rect">
               <a:avLst/>
@@ -3153,7 +3153,7 @@
             <a:p>
               <a:pPr algn="l" marL="0" marR="0" indent="0">
                 <a:lnSpc>
-                  <a:spcPts val="880"/>
+                  <a:spcPts val="1120"/>
                 </a:lnSpc>
                 <a:spcBef>
                   <a:spcPts val="0"/>
@@ -3163,7 +3163,7 @@
                 </a:spcAft>
               </a:pPr>
               <a:r>
-                <a:rPr sz="880">
+                <a:rPr sz="1120">
                   <a:solidFill>
                     <a:srgbClr val="4D4D4D">
                       <a:alpha val="100000"/>
@@ -3185,8 +3185,8 @@
           </p:nvSpPr>
           <p:spPr>
             <a:xfrm>
-              <a:off x="692708" y="3937929"/>
-              <a:ext cx="279714" cy="80101"/>
+              <a:off x="756929" y="3989157"/>
+              <a:ext cx="355518" cy="101955"/>
             </a:xfrm>
             <a:prstGeom prst="rect">
               <a:avLst/>
@@ -3199,7 +3199,7 @@
             <a:p>
               <a:pPr algn="l" marL="0" marR="0" indent="0">
                 <a:lnSpc>
-                  <a:spcPts val="880"/>
+                  <a:spcPts val="1120"/>
                 </a:lnSpc>
                 <a:spcBef>
                   <a:spcPts val="0"/>
@@ -3209,7 +3209,7 @@
                 </a:spcAft>
               </a:pPr>
               <a:r>
-                <a:rPr sz="880">
+                <a:rPr sz="1120">
                   <a:solidFill>
                     <a:srgbClr val="4D4D4D">
                       <a:alpha val="100000"/>
@@ -3231,8 +3231,8 @@
           </p:nvSpPr>
           <p:spPr>
             <a:xfrm>
-              <a:off x="692708" y="3136708"/>
-              <a:ext cx="279714" cy="80101"/>
+              <a:off x="756929" y="3266897"/>
+              <a:ext cx="355518" cy="101955"/>
             </a:xfrm>
             <a:prstGeom prst="rect">
               <a:avLst/>
@@ -3245,7 +3245,7 @@
             <a:p>
               <a:pPr algn="l" marL="0" marR="0" indent="0">
                 <a:lnSpc>
-                  <a:spcPts val="880"/>
+                  <a:spcPts val="1120"/>
                 </a:lnSpc>
                 <a:spcBef>
                   <a:spcPts val="0"/>
@@ -3255,7 +3255,7 @@
                 </a:spcAft>
               </a:pPr>
               <a:r>
-                <a:rPr sz="880">
+                <a:rPr sz="1120">
                   <a:solidFill>
                     <a:srgbClr val="4D4D4D">
                       <a:alpha val="100000"/>
@@ -3277,8 +3277,8 @@
           </p:nvSpPr>
           <p:spPr>
             <a:xfrm>
-              <a:off x="2481249" y="5785772"/>
-              <a:ext cx="124358" cy="80101"/>
+              <a:off x="2586500" y="5693022"/>
+              <a:ext cx="158008" cy="101955"/>
             </a:xfrm>
             <a:prstGeom prst="rect">
               <a:avLst/>
@@ -3291,7 +3291,7 @@
             <a:p>
               <a:pPr algn="l" marL="0" marR="0" indent="0">
                 <a:lnSpc>
-                  <a:spcPts val="880"/>
+                  <a:spcPts val="1120"/>
                 </a:lnSpc>
                 <a:spcBef>
                   <a:spcPts val="0"/>
@@ -3301,7 +3301,7 @@
                 </a:spcAft>
               </a:pPr>
               <a:r>
-                <a:rPr sz="880">
+                <a:rPr sz="1120">
                   <a:solidFill>
                     <a:srgbClr val="4D4D4D">
                       <a:alpha val="100000"/>
@@ -3323,8 +3323,8 @@
           </p:nvSpPr>
           <p:spPr>
             <a:xfrm>
-              <a:off x="4271605" y="5785772"/>
-              <a:ext cx="124358" cy="80101"/>
+              <a:off x="4335277" y="5693022"/>
+              <a:ext cx="158008" cy="101955"/>
             </a:xfrm>
             <a:prstGeom prst="rect">
               <a:avLst/>
@@ -3337,7 +3337,7 @@
             <a:p>
               <a:pPr algn="l" marL="0" marR="0" indent="0">
                 <a:lnSpc>
-                  <a:spcPts val="880"/>
+                  <a:spcPts val="1120"/>
                 </a:lnSpc>
                 <a:spcBef>
                   <a:spcPts val="0"/>
@@ -3347,7 +3347,7 @@
                 </a:spcAft>
               </a:pPr>
               <a:r>
-                <a:rPr sz="880">
+                <a:rPr sz="1120">
                   <a:solidFill>
                     <a:srgbClr val="4D4D4D">
                       <a:alpha val="100000"/>
@@ -3369,8 +3369,8 @@
           </p:nvSpPr>
           <p:spPr>
             <a:xfrm>
-              <a:off x="6061961" y="5785772"/>
-              <a:ext cx="124358" cy="80101"/>
+              <a:off x="6084055" y="5693022"/>
+              <a:ext cx="158008" cy="101955"/>
             </a:xfrm>
             <a:prstGeom prst="rect">
               <a:avLst/>
@@ -3383,7 +3383,7 @@
             <a:p>
               <a:pPr algn="l" marL="0" marR="0" indent="0">
                 <a:lnSpc>
-                  <a:spcPts val="880"/>
+                  <a:spcPts val="1120"/>
                 </a:lnSpc>
                 <a:spcBef>
                   <a:spcPts val="0"/>
@@ -3393,7 +3393,7 @@
                 </a:spcAft>
               </a:pPr>
               <a:r>
-                <a:rPr sz="880">
+                <a:rPr sz="1120">
                   <a:solidFill>
                     <a:srgbClr val="4D4D4D">
                       <a:alpha val="100000"/>
@@ -3415,8 +3415,8 @@
           </p:nvSpPr>
           <p:spPr>
             <a:xfrm>
-              <a:off x="7852317" y="5785772"/>
-              <a:ext cx="124358" cy="80101"/>
+              <a:off x="7832832" y="5693022"/>
+              <a:ext cx="158008" cy="101955"/>
             </a:xfrm>
             <a:prstGeom prst="rect">
               <a:avLst/>
@@ -3429,7 +3429,7 @@
             <a:p>
               <a:pPr algn="l" marL="0" marR="0" indent="0">
                 <a:lnSpc>
-                  <a:spcPts val="880"/>
+                  <a:spcPts val="1120"/>
                 </a:lnSpc>
                 <a:spcBef>
                   <a:spcPts val="0"/>
@@ -3439,7 +3439,7 @@
                 </a:spcAft>
               </a:pPr>
               <a:r>
-                <a:rPr sz="880">
+                <a:rPr sz="1120">
                   <a:solidFill>
                     <a:srgbClr val="4D4D4D">
                       <a:alpha val="100000"/>
@@ -3461,8 +3461,8 @@
           </p:nvSpPr>
           <p:spPr>
             <a:xfrm>
-              <a:off x="4228251" y="5925448"/>
-              <a:ext cx="1195760" cy="100218"/>
+              <a:off x="4134460" y="5870717"/>
+              <a:ext cx="1521470" cy="127558"/>
             </a:xfrm>
             <a:prstGeom prst="rect">
               <a:avLst/>
@@ -3475,7 +3475,7 @@
             <a:p>
               <a:pPr algn="l" marL="0" marR="0" indent="0">
                 <a:lnSpc>
-                  <a:spcPts val="1100"/>
+                  <a:spcPts val="1400"/>
                 </a:lnSpc>
                 <a:spcBef>
                   <a:spcPts val="0"/>
@@ -3485,7 +3485,7 @@
                 </a:spcAft>
               </a:pPr>
               <a:r>
-                <a:rPr sz="1100">
+                <a:rPr sz="1400">
                   <a:solidFill>
                     <a:srgbClr val="000000">
                       <a:alpha val="100000"/>
@@ -3507,8 +3507,8 @@
           </p:nvSpPr>
           <p:spPr>
             <a:xfrm rot="-5400000">
-              <a:off x="-87047" y="4103109"/>
-              <a:ext cx="1327891" cy="100218"/>
+              <a:off x="-235221" y="4134324"/>
+              <a:ext cx="1689536" cy="127558"/>
             </a:xfrm>
             <a:prstGeom prst="rect">
               <a:avLst/>
@@ -3521,7 +3521,7 @@
             <a:p>
               <a:pPr algn="l" marL="0" marR="0" indent="0">
                 <a:lnSpc>
-                  <a:spcPts val="1100"/>
+                  <a:spcPts val="1400"/>
                 </a:lnSpc>
                 <a:spcBef>
                   <a:spcPts val="0"/>
@@ -3531,7 +3531,7 @@
                 </a:spcAft>
               </a:pPr>
               <a:r>
-                <a:rPr sz="1100">
+                <a:rPr sz="1400">
                   <a:solidFill>
                     <a:srgbClr val="000000">
                       <a:alpha val="100000"/>
@@ -3553,7 +3553,7 @@
           </p:nvSpPr>
           <p:spPr>
             <a:xfrm>
-              <a:off x="3609655" y="2264798"/>
+              <a:off x="3402128" y="2407465"/>
               <a:ext cx="175564" cy="0"/>
             </a:xfrm>
             <a:custGeom>
@@ -3593,7 +3593,7 @@
           </p:nvSpPr>
           <p:spPr>
             <a:xfrm>
-              <a:off x="4850228" y="2264798"/>
+              <a:off x="4919957" y="2407465"/>
               <a:ext cx="175564" cy="0"/>
             </a:xfrm>
             <a:custGeom>
@@ -3633,8 +3633,8 @@
           </p:nvSpPr>
           <p:spPr>
             <a:xfrm>
-              <a:off x="3876754" y="2224748"/>
-              <a:ext cx="881938" cy="80101"/>
+              <a:off x="3688206" y="2356487"/>
+              <a:ext cx="1121237" cy="101955"/>
             </a:xfrm>
             <a:prstGeom prst="rect">
               <a:avLst/>
@@ -3647,7 +3647,7 @@
             <a:p>
               <a:pPr algn="l" marL="0" marR="0" indent="0">
                 <a:lnSpc>
-                  <a:spcPts val="880"/>
+                  <a:spcPts val="1120"/>
                 </a:lnSpc>
                 <a:spcBef>
                   <a:spcPts val="0"/>
@@ -3657,7 +3657,7 @@
                 </a:spcAft>
               </a:pPr>
               <a:r>
-                <a:rPr sz="880">
+                <a:rPr sz="1120">
                   <a:solidFill>
                     <a:srgbClr val="000000">
                       <a:alpha val="100000"/>
@@ -3679,8 +3679,8 @@
           </p:nvSpPr>
           <p:spPr>
             <a:xfrm>
-              <a:off x="5117327" y="2224748"/>
-              <a:ext cx="947226" cy="80101"/>
+              <a:off x="5206035" y="2356487"/>
+              <a:ext cx="1204173" cy="101955"/>
             </a:xfrm>
             <a:prstGeom prst="rect">
               <a:avLst/>
@@ -3693,7 +3693,7 @@
             <a:p>
               <a:pPr algn="l" marL="0" marR="0" indent="0">
                 <a:lnSpc>
-                  <a:spcPts val="880"/>
+                  <a:spcPts val="1120"/>
                 </a:lnSpc>
                 <a:spcBef>
                   <a:spcPts val="0"/>
@@ -3703,7 +3703,7 @@
                 </a:spcAft>
               </a:pPr>
               <a:r>
-                <a:rPr sz="880">
+                <a:rPr sz="1120">
                   <a:solidFill>
                     <a:srgbClr val="000000">
                       <a:alpha val="100000"/>
@@ -3725,8 +3725,8 @@
           </p:nvSpPr>
           <p:spPr>
             <a:xfrm>
-              <a:off x="1035053" y="1896563"/>
-              <a:ext cx="3984498" cy="91165"/>
+              <a:off x="1192159" y="1977589"/>
+              <a:ext cx="4782220" cy="109362"/>
             </a:xfrm>
             <a:prstGeom prst="rect">
               <a:avLst/>
@@ -3739,7 +3739,7 @@
             <a:p>
               <a:pPr algn="l" marL="0" marR="0" indent="0">
                 <a:lnSpc>
-                  <a:spcPts val="1000"/>
+                  <a:spcPts val="1200"/>
                 </a:lnSpc>
                 <a:spcBef>
                   <a:spcPts val="0"/>
@@ -3749,7 +3749,7 @@
                 </a:spcAft>
               </a:pPr>
               <a:r>
-                <a:rPr sz="1000">
+                <a:rPr sz="1200">
                   <a:solidFill>
                     <a:srgbClr val="404040">
                       <a:alpha val="100000"/>
@@ -3771,8 +3771,8 @@
           </p:nvSpPr>
           <p:spPr>
             <a:xfrm>
-              <a:off x="1035053" y="1669789"/>
-              <a:ext cx="921898" cy="120152"/>
+              <a:off x="1192159" y="1688767"/>
+              <a:ext cx="1173723" cy="153070"/>
             </a:xfrm>
             <a:prstGeom prst="rect">
               <a:avLst/>
@@ -3785,7 +3785,7 @@
             <a:p>
               <a:pPr algn="l" marL="0" marR="0" indent="0">
                 <a:lnSpc>
-                  <a:spcPts val="1320"/>
+                  <a:spcPts val="1680"/>
                 </a:lnSpc>
                 <a:spcBef>
                   <a:spcPts val="0"/>
@@ -3795,7 +3795,7 @@
                 </a:spcAft>
               </a:pPr>
               <a:r>
-                <a:rPr sz="1320">
+                <a:rPr sz="1680">
                   <a:solidFill>
                     <a:srgbClr val="000000">
                       <a:alpha val="100000"/>

</xml_diff>